<commit_message>
Update hackathon pitch deck
</commit_message>
<xml_diff>
--- a/deck/Jan-Awaaz.pptx
+++ b/deck/Jan-Awaaz.pptx
@@ -4,6 +4,9 @@
   <p:sldMasterIdLst>
     <p:sldMasterId id="2147483648" r:id="rId1"/>
   </p:sldMasterIdLst>
+  <p:notesMasterIdLst>
+    <p:notesMasterId r:id="rId14"/>
+  </p:notesMasterIdLst>
   <p:sldIdLst>
     <p:sldId id="256" r:id="rId2"/>
     <p:sldId id="257" r:id="rId3"/>
@@ -18,9 +21,6 @@
     <p:sldId id="266" r:id="rId12"/>
     <p:sldId id="267" r:id="rId13"/>
   </p:sldIdLst>
-  <p:notesMasterIdLst>
-    <p:notesMasterId r:id="rId14"/>
-  </p:notesMasterIdLst>
   <p:sldSz cx="12192000" cy="6858000"/>
   <p:notesSz cx="6858000" cy="12192000"/>
   <p:defaultTextStyle>
@@ -115,6 +115,11 @@
       </a:defRPr>
     </a:lvl9pPr>
   </p:defaultTextStyle>
+  <p:extLst>
+    <p:ext uri="{EFAFB233-063F-42B5-8137-9DF3F51BA10A}">
+      <p15:sldGuideLst xmlns:p15="http://schemas.microsoft.com/office/powerpoint/2012/main"/>
+    </p:ext>
+  </p:extLst>
 </p:presentation>
 </file>
 
@@ -140,234 +145,10 @@
           <a:chExt cx="0" cy="0"/>
         </a:xfrm>
       </p:grpSpPr>
-      <p:sp>
-        <p:nvSpPr>
-          <p:cNvPr id="2" name="Header Placeholder 1"/>
-          <p:cNvSpPr>
-            <a:spLocks noGrp="1"/>
-          </p:cNvSpPr>
-          <p:nvPr>
-            <p:ph type="hdr" sz="quarter"/>
-          </p:nvPr>
-        </p:nvSpPr>
-        <p:spPr>
-          <a:xfrm>
-            <a:off x="0" y="0"/>
-            <a:ext cx="2971800" cy="458788"/>
-          </a:xfrm>
-          <a:prstGeom prst="rect">
-            <a:avLst/>
-          </a:prstGeom>
-        </p:spPr>
-        <p:txBody>
-          <a:bodyPr vert="horz" lIns="91440" tIns="45720" rIns="91440" bIns="45720" rtlCol="0"/>
-          <a:lstStyle>
-            <a:lvl1pPr algn="l">
-              <a:defRPr sz="1200"/>
-            </a:lvl1pPr>
-          </a:lstStyle>
-          <a:p>
-            <a:endParaRPr lang="en-US"/>
-          </a:p>
-        </p:txBody>
-      </p:sp>
-      <p:sp>
-        <p:nvSpPr>
-          <p:cNvPr id="3" name="Date Placeholder 2"/>
-          <p:cNvSpPr>
-            <a:spLocks noGrp="1"/>
-          </p:cNvSpPr>
-          <p:nvPr>
-            <p:ph type="dt" idx="1"/>
-          </p:nvPr>
-        </p:nvSpPr>
-        <p:spPr>
-          <a:xfrm>
-            <a:off x="3884613" y="0"/>
-            <a:ext cx="2971800" cy="458788"/>
-          </a:xfrm>
-          <a:prstGeom prst="rect">
-            <a:avLst/>
-          </a:prstGeom>
-        </p:spPr>
-        <p:txBody>
-          <a:bodyPr vert="horz" lIns="91440" tIns="45720" rIns="91440" bIns="45720" rtlCol="0"/>
-          <a:lstStyle>
-            <a:lvl1pPr algn="r">
-              <a:defRPr sz="1200"/>
-            </a:lvl1pPr>
-          </a:lstStyle>
-          <a:p>
-            <a:fld id="{5282F153-3F37-0F45-9E97-73ACFA13230C}" type="datetimeFigureOut">
-              <a:rPr lang="en-US"/>
-              <a:t>7/23/19</a:t>
-            </a:fld>
-            <a:endParaRPr lang="en-US"/>
-          </a:p>
-        </p:txBody>
-      </p:sp>
-      <p:sp>
-        <p:nvSpPr>
-          <p:cNvPr id="4" name="Slide Image Placeholder 3"/>
-          <p:cNvSpPr>
-            <a:spLocks noGrp="1" noRot="1" noChangeAspect="1"/>
-          </p:cNvSpPr>
-          <p:nvPr>
-            <p:ph type="sldImg" idx="2"/>
-          </p:nvPr>
-        </p:nvSpPr>
-        <p:spPr>
-          <a:xfrm>
-            <a:off x="685800" y="1143000"/>
-            <a:ext cx="5486400" cy="3086100"/>
-          </a:xfrm>
-          <a:prstGeom prst="rect">
-            <a:avLst/>
-          </a:prstGeom>
-          <a:noFill/>
-          <a:ln w="12700">
-            <a:solidFill>
-              <a:prstClr val="black"/>
-            </a:solidFill>
-          </a:ln>
-        </p:spPr>
-        <p:txBody>
-          <a:bodyPr vert="horz" lIns="91440" tIns="45720" rIns="91440" bIns="45720" rtlCol="0" anchor="ctr"/>
-          <a:lstStyle/>
-          <a:p>
-            <a:endParaRPr lang="en-US"/>
-          </a:p>
-        </p:txBody>
-      </p:sp>
-      <p:sp>
-        <p:nvSpPr>
-          <p:cNvPr id="5" name="Notes Placeholder 4"/>
-          <p:cNvSpPr>
-            <a:spLocks noGrp="1"/>
-          </p:cNvSpPr>
-          <p:nvPr>
-            <p:ph type="body" sz="quarter" idx="3"/>
-          </p:nvPr>
-        </p:nvSpPr>
-        <p:spPr>
-          <a:xfrm>
-            <a:off x="685800" y="4400550"/>
-            <a:ext cx="5486400" cy="3600450"/>
-          </a:xfrm>
-          <a:prstGeom prst="rect">
-            <a:avLst/>
-          </a:prstGeom>
-        </p:spPr>
-        <p:txBody>
-          <a:bodyPr vert="horz" lIns="91440" tIns="45720" rIns="91440" bIns="45720" rtlCol="0"/>
-          <a:lstStyle/>
-          <a:p>
-            <a:pPr lvl="0"/>
-            <a:r>
-              <a:rPr lang="en-US"/>
-              <a:t>Click to edit Master text styles</a:t>
-            </a:r>
-          </a:p>
-          <a:p>
-            <a:pPr lvl="1"/>
-            <a:r>
-              <a:rPr lang="en-US"/>
-              <a:t>Second level</a:t>
-            </a:r>
-          </a:p>
-          <a:p>
-            <a:pPr lvl="2"/>
-            <a:r>
-              <a:rPr lang="en-US"/>
-              <a:t>Third level</a:t>
-            </a:r>
-          </a:p>
-          <a:p>
-            <a:pPr lvl="3"/>
-            <a:r>
-              <a:rPr lang="en-US"/>
-              <a:t>Fourth level</a:t>
-            </a:r>
-          </a:p>
-          <a:p>
-            <a:pPr lvl="4"/>
-            <a:r>
-              <a:rPr lang="en-US"/>
-              <a:t>Fifth level</a:t>
-            </a:r>
-          </a:p>
-        </p:txBody>
-      </p:sp>
-      <p:sp>
-        <p:nvSpPr>
-          <p:cNvPr id="6" name="Footer Placeholder 5"/>
-          <p:cNvSpPr>
-            <a:spLocks noGrp="1"/>
-          </p:cNvSpPr>
-          <p:nvPr>
-            <p:ph type="ftr" sz="quarter" idx="4"/>
-          </p:nvPr>
-        </p:nvSpPr>
-        <p:spPr>
-          <a:xfrm>
-            <a:off x="0" y="8685213"/>
-            <a:ext cx="2971800" cy="458787"/>
-          </a:xfrm>
-          <a:prstGeom prst="rect">
-            <a:avLst/>
-          </a:prstGeom>
-        </p:spPr>
-        <p:txBody>
-          <a:bodyPr vert="horz" lIns="91440" tIns="45720" rIns="91440" bIns="45720" rtlCol="0" anchor="b"/>
-          <a:lstStyle>
-            <a:lvl1pPr algn="l">
-              <a:defRPr sz="1200"/>
-            </a:lvl1pPr>
-          </a:lstStyle>
-          <a:p>
-            <a:endParaRPr lang="en-US"/>
-          </a:p>
-        </p:txBody>
-      </p:sp>
-      <p:sp>
-        <p:nvSpPr>
-          <p:cNvPr id="7" name="Slide Number Placeholder 6"/>
-          <p:cNvSpPr>
-            <a:spLocks noGrp="1"/>
-          </p:cNvSpPr>
-          <p:nvPr>
-            <p:ph type="sldNum" sz="quarter" idx="5"/>
-          </p:nvPr>
-        </p:nvSpPr>
-        <p:spPr>
-          <a:xfrm>
-            <a:off x="3884613" y="8685213"/>
-            <a:ext cx="2971800" cy="458787"/>
-          </a:xfrm>
-          <a:prstGeom prst="rect">
-            <a:avLst/>
-          </a:prstGeom>
-        </p:spPr>
-        <p:txBody>
-          <a:bodyPr vert="horz" lIns="91440" tIns="45720" rIns="91440" bIns="45720" rtlCol="0" anchor="b"/>
-          <a:lstStyle>
-            <a:lvl1pPr algn="r">
-              <a:defRPr sz="1200"/>
-            </a:lvl1pPr>
-          </a:lstStyle>
-          <a:p>
-            <a:fld id="{CE5E9CC1-C706-0F49-92D6-E571CC5EEA8F}" type="slidenum">
-              <a:rPr lang="en-US"/>
-              <a:t>‹#›</a:t>
-            </a:fld>
-            <a:endParaRPr lang="en-US"/>
-          </a:p>
-        </p:txBody>
-      </p:sp>
     </p:spTree>
     <p:extLst>
       <p:ext uri="{BB962C8B-B14F-4D97-AF65-F5344CB8AC3E}">
-        <p14:creationId xmlns:p14="http://schemas.microsoft.com/office/powerpoint/2010/main" val="1024086991"/>
+        <p14:creationId xmlns:p14="http://schemas.microsoft.com/office/powerpoint/2010/main" val="3031936185"/>
       </p:ext>
     </p:extLst>
   </p:cSld>
@@ -511,10 +292,6 @@
           <a:bodyPr/>
           <a:lstStyle/>
           <a:p>
-            <a:r>
-              <a:rPr lang="en-US" dirty="0"/>
-              <a:t/>
-            </a:r>
             <a:endParaRPr lang="en-US" dirty="0"/>
           </a:p>
         </p:txBody>
@@ -599,10 +376,6 @@
           <a:bodyPr/>
           <a:lstStyle/>
           <a:p>
-            <a:r>
-              <a:rPr lang="en-US" dirty="0"/>
-              <a:t/>
-            </a:r>
             <a:endParaRPr lang="en-US" dirty="0"/>
           </a:p>
         </p:txBody>
@@ -687,10 +460,6 @@
           <a:bodyPr/>
           <a:lstStyle/>
           <a:p>
-            <a:r>
-              <a:rPr lang="en-US" dirty="0"/>
-              <a:t/>
-            </a:r>
             <a:endParaRPr lang="en-US" dirty="0"/>
           </a:p>
         </p:txBody>
@@ -775,10 +544,6 @@
           <a:bodyPr/>
           <a:lstStyle/>
           <a:p>
-            <a:r>
-              <a:rPr lang="en-US" dirty="0"/>
-              <a:t/>
-            </a:r>
             <a:endParaRPr lang="en-US" dirty="0"/>
           </a:p>
         </p:txBody>
@@ -863,10 +628,6 @@
           <a:bodyPr/>
           <a:lstStyle/>
           <a:p>
-            <a:r>
-              <a:rPr lang="en-US" dirty="0"/>
-              <a:t/>
-            </a:r>
             <a:endParaRPr lang="en-US" dirty="0"/>
           </a:p>
         </p:txBody>
@@ -951,10 +712,6 @@
           <a:bodyPr/>
           <a:lstStyle/>
           <a:p>
-            <a:r>
-              <a:rPr lang="en-US" dirty="0"/>
-              <a:t/>
-            </a:r>
             <a:endParaRPr lang="en-US" dirty="0"/>
           </a:p>
         </p:txBody>
@@ -1039,10 +796,6 @@
           <a:bodyPr/>
           <a:lstStyle/>
           <a:p>
-            <a:r>
-              <a:rPr lang="en-US" dirty="0"/>
-              <a:t/>
-            </a:r>
             <a:endParaRPr lang="en-US" dirty="0"/>
           </a:p>
         </p:txBody>
@@ -1127,10 +880,6 @@
           <a:bodyPr/>
           <a:lstStyle/>
           <a:p>
-            <a:r>
-              <a:rPr lang="en-US" dirty="0"/>
-              <a:t/>
-            </a:r>
             <a:endParaRPr lang="en-US" dirty="0"/>
           </a:p>
         </p:txBody>
@@ -1215,10 +964,6 @@
           <a:bodyPr/>
           <a:lstStyle/>
           <a:p>
-            <a:r>
-              <a:rPr lang="en-US" dirty="0"/>
-              <a:t/>
-            </a:r>
             <a:endParaRPr lang="en-US" dirty="0"/>
           </a:p>
         </p:txBody>
@@ -1303,10 +1048,6 @@
           <a:bodyPr/>
           <a:lstStyle/>
           <a:p>
-            <a:r>
-              <a:rPr lang="en-US" dirty="0"/>
-              <a:t/>
-            </a:r>
             <a:endParaRPr lang="en-US" dirty="0"/>
           </a:p>
         </p:txBody>
@@ -1391,10 +1132,6 @@
           <a:bodyPr/>
           <a:lstStyle/>
           <a:p>
-            <a:r>
-              <a:rPr lang="en-US" dirty="0"/>
-              <a:t/>
-            </a:r>
             <a:endParaRPr lang="en-US" dirty="0"/>
           </a:p>
         </p:txBody>
@@ -1479,10 +1216,6 @@
           <a:bodyPr/>
           <a:lstStyle/>
           <a:p>
-            <a:r>
-              <a:rPr lang="en-US" dirty="0"/>
-              <a:t/>
-            </a:r>
             <a:endParaRPr lang="en-US" dirty="0"/>
           </a:p>
         </p:txBody>
@@ -1556,6 +1289,11 @@
 <file path=ppt/slideMasters/slideMaster1.xml><?xml version="1.0" encoding="utf-8"?>
 <p:sldMaster xmlns:a="http://schemas.openxmlformats.org/drawingml/2006/main" xmlns:r="http://schemas.openxmlformats.org/officeDocument/2006/relationships" xmlns:p="http://schemas.openxmlformats.org/presentationml/2006/main">
   <p:cSld>
+    <p:bg>
+      <p:bgRef idx="1001">
+        <a:schemeClr val="bg1"/>
+      </p:bgRef>
+    </p:bg>
     <p:spTree>
       <p:nvGrpSpPr>
         <p:cNvPr id="1" name=""/>
@@ -1838,6 +1576,7 @@
         <a:solidFill>
           <a:srgbClr val="FFFFFF"/>
         </a:solidFill>
+        <a:effectLst/>
       </p:bgPr>
     </p:bg>
     <p:spTree>
@@ -1873,6 +1612,13 @@
           </a:solidFill>
           <a:ln/>
         </p:spPr>
+        <p:txBody>
+          <a:bodyPr/>
+          <a:lstStyle/>
+          <a:p>
+            <a:endParaRPr lang="en-IN"/>
+          </a:p>
+        </p:txBody>
       </p:sp>
       <p:sp>
         <p:nvSpPr>
@@ -1893,6 +1639,13 @@
           </a:solidFill>
           <a:ln/>
         </p:spPr>
+        <p:txBody>
+          <a:bodyPr/>
+          <a:lstStyle/>
+          <a:p>
+            <a:endParaRPr lang="en-IN"/>
+          </a:p>
+        </p:txBody>
       </p:sp>
       <p:sp>
         <p:nvSpPr>
@@ -1915,6 +1668,13 @@
           </a:solidFill>
           <a:ln/>
         </p:spPr>
+        <p:txBody>
+          <a:bodyPr/>
+          <a:lstStyle/>
+          <a:p>
+            <a:endParaRPr lang="en-IN"/>
+          </a:p>
+        </p:txBody>
       </p:sp>
       <p:sp>
         <p:nvSpPr>
@@ -1937,7 +1697,7 @@
           <a:bodyPr wrap="square" rtlCol="0" anchor="ctr"/>
           <a:lstStyle/>
           <a:p>
-            <a:pPr algn="ctr" indent="0" marL="0">
+            <a:pPr marL="0" indent="0" algn="ctr">
               <a:buNone/>
             </a:pPr>
             <a:r>
@@ -1976,7 +1736,7 @@
           <a:bodyPr wrap="square" rtlCol="0" anchor="ctr"/>
           <a:lstStyle/>
           <a:p>
-            <a:pPr indent="0" marL="0">
+            <a:pPr marL="0" indent="0">
               <a:buNone/>
             </a:pPr>
             <a:r>
@@ -2015,7 +1775,7 @@
           <a:bodyPr wrap="square" rtlCol="0" anchor="ctr"/>
           <a:lstStyle/>
           <a:p>
-            <a:pPr indent="0" marL="0">
+            <a:pPr marL="0" indent="0">
               <a:buNone/>
             </a:pPr>
             <a:r>
@@ -2059,13 +1819,20 @@
             <a:prstDash val="solid"/>
           </a:ln>
           <a:effectLst>
-            <a:outerShdw sx="100000" sy="100000" kx="0" ky="0" algn="bl" rotWithShape="0" blurRad="101600" dist="25400" dir="5400000">
+            <a:outerShdw blurRad="101600" dist="25400" dir="5400000" algn="bl" rotWithShape="0">
               <a:srgbClr val="B9C2D0">
                 <a:alpha val="35000"/>
               </a:srgbClr>
             </a:outerShdw>
           </a:effectLst>
         </p:spPr>
+        <p:txBody>
+          <a:bodyPr/>
+          <a:lstStyle/>
+          <a:p>
+            <a:endParaRPr lang="en-IN"/>
+          </a:p>
+        </p:txBody>
       </p:sp>
       <p:sp>
         <p:nvSpPr>
@@ -2088,7 +1855,7 @@
           <a:bodyPr wrap="square" rtlCol="0" anchor="ctr"/>
           <a:lstStyle/>
           <a:p>
-            <a:pPr indent="0" marL="0">
+            <a:pPr marL="0" indent="0">
               <a:buNone/>
             </a:pPr>
             <a:r>
@@ -2127,7 +1894,7 @@
           <a:bodyPr wrap="square" rtlCol="0" anchor="ctr"/>
           <a:lstStyle/>
           <a:p>
-            <a:pPr indent="0" marL="0">
+            <a:pPr marL="0" indent="0">
               <a:buNone/>
             </a:pPr>
             <a:r>
@@ -2166,6 +1933,13 @@
           </a:solidFill>
           <a:ln/>
         </p:spPr>
+        <p:txBody>
+          <a:bodyPr/>
+          <a:lstStyle/>
+          <a:p>
+            <a:endParaRPr lang="en-IN"/>
+          </a:p>
+        </p:txBody>
       </p:sp>
       <p:sp>
         <p:nvSpPr>
@@ -2188,6 +1962,13 @@
           </a:solidFill>
           <a:ln/>
         </p:spPr>
+        <p:txBody>
+          <a:bodyPr/>
+          <a:lstStyle/>
+          <a:p>
+            <a:endParaRPr lang="en-IN"/>
+          </a:p>
+        </p:txBody>
       </p:sp>
       <p:sp>
         <p:nvSpPr>
@@ -2210,7 +1991,7 @@
           <a:bodyPr wrap="square" rtlCol="0" anchor="ctr"/>
           <a:lstStyle/>
           <a:p>
-            <a:pPr indent="0" marL="0">
+            <a:pPr marL="0" indent="0">
               <a:buNone/>
             </a:pPr>
             <a:r>
@@ -2249,6 +2030,13 @@
           </a:solidFill>
           <a:ln/>
         </p:spPr>
+        <p:txBody>
+          <a:bodyPr/>
+          <a:lstStyle/>
+          <a:p>
+            <a:endParaRPr lang="en-IN"/>
+          </a:p>
+        </p:txBody>
       </p:sp>
       <p:sp>
         <p:nvSpPr>
@@ -2271,6 +2059,13 @@
           </a:solidFill>
           <a:ln/>
         </p:spPr>
+        <p:txBody>
+          <a:bodyPr/>
+          <a:lstStyle/>
+          <a:p>
+            <a:endParaRPr lang="en-IN"/>
+          </a:p>
+        </p:txBody>
       </p:sp>
       <p:sp>
         <p:nvSpPr>
@@ -2293,7 +2088,7 @@
           <a:bodyPr wrap="square" rtlCol="0" anchor="ctr"/>
           <a:lstStyle/>
           <a:p>
-            <a:pPr indent="0" marL="0">
+            <a:pPr marL="0" indent="0">
               <a:buNone/>
             </a:pPr>
             <a:r>
@@ -2332,6 +2127,13 @@
           </a:solidFill>
           <a:ln/>
         </p:spPr>
+        <p:txBody>
+          <a:bodyPr/>
+          <a:lstStyle/>
+          <a:p>
+            <a:endParaRPr lang="en-IN"/>
+          </a:p>
+        </p:txBody>
       </p:sp>
       <p:sp>
         <p:nvSpPr>
@@ -2354,6 +2156,13 @@
           </a:solidFill>
           <a:ln/>
         </p:spPr>
+        <p:txBody>
+          <a:bodyPr/>
+          <a:lstStyle/>
+          <a:p>
+            <a:endParaRPr lang="en-IN"/>
+          </a:p>
+        </p:txBody>
       </p:sp>
       <p:sp>
         <p:nvSpPr>
@@ -2376,7 +2185,7 @@
           <a:bodyPr wrap="square" rtlCol="0" anchor="ctr"/>
           <a:lstStyle/>
           <a:p>
-            <a:pPr indent="0" marL="0">
+            <a:pPr marL="0" indent="0">
               <a:buNone/>
             </a:pPr>
             <a:r>
@@ -2415,6 +2224,13 @@
           </a:solidFill>
           <a:ln/>
         </p:spPr>
+        <p:txBody>
+          <a:bodyPr/>
+          <a:lstStyle/>
+          <a:p>
+            <a:endParaRPr lang="en-IN"/>
+          </a:p>
+        </p:txBody>
       </p:sp>
       <p:sp>
         <p:nvSpPr>
@@ -2437,6 +2253,13 @@
           </a:solidFill>
           <a:ln/>
         </p:spPr>
+        <p:txBody>
+          <a:bodyPr/>
+          <a:lstStyle/>
+          <a:p>
+            <a:endParaRPr lang="en-IN"/>
+          </a:p>
+        </p:txBody>
       </p:sp>
       <p:sp>
         <p:nvSpPr>
@@ -2459,7 +2282,7 @@
           <a:bodyPr wrap="square" rtlCol="0" anchor="ctr"/>
           <a:lstStyle/>
           <a:p>
-            <a:pPr indent="0" marL="0">
+            <a:pPr marL="0" indent="0">
               <a:buNone/>
             </a:pPr>
             <a:r>
@@ -2583,7 +2406,7 @@
           <a:bodyPr wrap="square" rtlCol="0" anchor="ctr"/>
           <a:lstStyle/>
           <a:p>
-            <a:pPr indent="0" marL="0">
+            <a:pPr marL="0" indent="0">
               <a:buNone/>
             </a:pPr>
             <a:r>
@@ -2620,6 +2443,13 @@
           </a:solidFill>
           <a:ln/>
         </p:spPr>
+        <p:txBody>
+          <a:bodyPr/>
+          <a:lstStyle/>
+          <a:p>
+            <a:endParaRPr lang="en-IN"/>
+          </a:p>
+        </p:txBody>
       </p:sp>
       <p:sp>
         <p:nvSpPr>
@@ -2642,7 +2472,7 @@
           <a:bodyPr wrap="square" rtlCol="0" anchor="ctr"/>
           <a:lstStyle/>
           <a:p>
-            <a:pPr indent="0" marL="0">
+            <a:pPr marL="0" indent="0">
               <a:buNone/>
             </a:pPr>
             <a:r>
@@ -2681,7 +2511,7 @@
           <a:bodyPr wrap="square" rtlCol="0" anchor="ctr"/>
           <a:lstStyle/>
           <a:p>
-            <a:pPr algn="r" indent="0" marL="0">
+            <a:pPr marL="0" indent="0" algn="r">
               <a:buNone/>
             </a:pPr>
             <a:r>
@@ -2715,6 +2545,7 @@
         <a:solidFill>
           <a:srgbClr val="F5F7FB"/>
         </a:solidFill>
+        <a:effectLst/>
       </p:bgPr>
     </p:bg>
     <p:spTree>
@@ -2752,11 +2583,11 @@
           <a:bodyPr wrap="square" rtlCol="0" anchor="ctr"/>
           <a:lstStyle/>
           <a:p>
-            <a:pPr indent="0" marL="0">
-              <a:buNone/>
-            </a:pPr>
-            <a:r>
-              <a:rPr lang="en-US" sz="1200" b="1" spc="200" kern="0" dirty="0">
+            <a:pPr marL="0" indent="0">
+              <a:buNone/>
+            </a:pPr>
+            <a:r>
+              <a:rPr lang="en-US" sz="1200" b="1" kern="0" spc="200" dirty="0">
                 <a:solidFill>
                   <a:srgbClr val="4F46E5"/>
                 </a:solidFill>
@@ -2791,7 +2622,7 @@
           <a:bodyPr wrap="square" rtlCol="0" anchor="ctr"/>
           <a:lstStyle/>
           <a:p>
-            <a:pPr indent="0" marL="0">
+            <a:pPr marL="0" indent="0">
               <a:buNone/>
             </a:pPr>
             <a:r>
@@ -2835,13 +2666,20 @@
             <a:prstDash val="solid"/>
           </a:ln>
           <a:effectLst>
-            <a:outerShdw sx="100000" sy="100000" kx="0" ky="0" algn="bl" rotWithShape="0" blurRad="101600" dist="25400" dir="5400000">
+            <a:outerShdw blurRad="101600" dist="25400" dir="5400000" algn="bl" rotWithShape="0">
               <a:srgbClr val="B9C2D0">
                 <a:alpha val="35000"/>
               </a:srgbClr>
             </a:outerShdw>
           </a:effectLst>
         </p:spPr>
+        <p:txBody>
+          <a:bodyPr/>
+          <a:lstStyle/>
+          <a:p>
+            <a:endParaRPr lang="en-IN"/>
+          </a:p>
+        </p:txBody>
       </p:sp>
       <p:sp>
         <p:nvSpPr>
@@ -2864,7 +2702,7 @@
           <a:bodyPr wrap="square" rtlCol="0" anchor="ctr"/>
           <a:lstStyle/>
           <a:p>
-            <a:pPr algn="ctr" indent="0" marL="0">
+            <a:pPr marL="0" indent="0" algn="ctr">
               <a:buNone/>
             </a:pPr>
             <a:r>
@@ -2903,7 +2741,7 @@
           <a:bodyPr wrap="square" rtlCol="0" anchor="t"/>
           <a:lstStyle/>
           <a:p>
-            <a:pPr algn="ctr" indent="0" marL="0">
+            <a:pPr marL="0" indent="0" algn="ctr">
               <a:buNone/>
             </a:pPr>
             <a:r>
@@ -2947,13 +2785,20 @@
             <a:prstDash val="solid"/>
           </a:ln>
           <a:effectLst>
-            <a:outerShdw sx="100000" sy="100000" kx="0" ky="0" algn="bl" rotWithShape="0" blurRad="101600" dist="25400" dir="5400000">
+            <a:outerShdw blurRad="101600" dist="25400" dir="5400000" algn="bl" rotWithShape="0">
               <a:srgbClr val="B9C2D0">
                 <a:alpha val="35000"/>
               </a:srgbClr>
             </a:outerShdw>
           </a:effectLst>
         </p:spPr>
+        <p:txBody>
+          <a:bodyPr/>
+          <a:lstStyle/>
+          <a:p>
+            <a:endParaRPr lang="en-IN"/>
+          </a:p>
+        </p:txBody>
       </p:sp>
       <p:sp>
         <p:nvSpPr>
@@ -2976,7 +2821,7 @@
           <a:bodyPr wrap="square" rtlCol="0" anchor="ctr"/>
           <a:lstStyle/>
           <a:p>
-            <a:pPr algn="ctr" indent="0" marL="0">
+            <a:pPr marL="0" indent="0" algn="ctr">
               <a:buNone/>
             </a:pPr>
             <a:r>
@@ -3015,7 +2860,7 @@
           <a:bodyPr wrap="square" rtlCol="0" anchor="t"/>
           <a:lstStyle/>
           <a:p>
-            <a:pPr algn="ctr" indent="0" marL="0">
+            <a:pPr marL="0" indent="0" algn="ctr">
               <a:buNone/>
             </a:pPr>
             <a:r>
@@ -3059,13 +2904,20 @@
             <a:prstDash val="solid"/>
           </a:ln>
           <a:effectLst>
-            <a:outerShdw sx="100000" sy="100000" kx="0" ky="0" algn="bl" rotWithShape="0" blurRad="101600" dist="25400" dir="5400000">
+            <a:outerShdw blurRad="101600" dist="25400" dir="5400000" algn="bl" rotWithShape="0">
               <a:srgbClr val="B9C2D0">
                 <a:alpha val="35000"/>
               </a:srgbClr>
             </a:outerShdw>
           </a:effectLst>
         </p:spPr>
+        <p:txBody>
+          <a:bodyPr/>
+          <a:lstStyle/>
+          <a:p>
+            <a:endParaRPr lang="en-IN"/>
+          </a:p>
+        </p:txBody>
       </p:sp>
       <p:sp>
         <p:nvSpPr>
@@ -3088,7 +2940,7 @@
           <a:bodyPr wrap="square" rtlCol="0" anchor="ctr"/>
           <a:lstStyle/>
           <a:p>
-            <a:pPr algn="ctr" indent="0" marL="0">
+            <a:pPr marL="0" indent="0" algn="ctr">
               <a:buNone/>
             </a:pPr>
             <a:r>
@@ -3127,7 +2979,7 @@
           <a:bodyPr wrap="square" rtlCol="0" anchor="t"/>
           <a:lstStyle/>
           <a:p>
-            <a:pPr algn="ctr" indent="0" marL="0">
+            <a:pPr marL="0" indent="0" algn="ctr">
               <a:buNone/>
             </a:pPr>
             <a:r>
@@ -3166,7 +3018,7 @@
           <a:bodyPr wrap="square" rtlCol="0" anchor="ctr"/>
           <a:lstStyle/>
           <a:p>
-            <a:pPr indent="0" marL="0">
+            <a:pPr marL="0" indent="0">
               <a:buNone/>
             </a:pPr>
             <a:r>
@@ -3203,6 +3055,13 @@
           </a:solidFill>
           <a:ln/>
         </p:spPr>
+        <p:txBody>
+          <a:bodyPr/>
+          <a:lstStyle/>
+          <a:p>
+            <a:endParaRPr lang="en-IN"/>
+          </a:p>
+        </p:txBody>
       </p:sp>
       <p:sp>
         <p:nvSpPr>
@@ -3225,7 +3084,7 @@
           <a:bodyPr wrap="square" rtlCol="0" anchor="ctr"/>
           <a:lstStyle/>
           <a:p>
-            <a:pPr indent="0" marL="0">
+            <a:pPr marL="0" indent="0">
               <a:buNone/>
             </a:pPr>
             <a:r>
@@ -3264,7 +3123,7 @@
           <a:bodyPr wrap="square" rtlCol="0" anchor="ctr"/>
           <a:lstStyle/>
           <a:p>
-            <a:pPr algn="r" indent="0" marL="0">
+            <a:pPr marL="0" indent="0" algn="r">
               <a:buNone/>
             </a:pPr>
             <a:r>
@@ -3298,6 +3157,7 @@
         <a:solidFill>
           <a:srgbClr val="F5F7FB"/>
         </a:solidFill>
+        <a:effectLst/>
       </p:bgPr>
     </p:bg>
     <p:spTree>
@@ -3335,11 +3195,11 @@
           <a:bodyPr wrap="square" rtlCol="0" anchor="ctr"/>
           <a:lstStyle/>
           <a:p>
-            <a:pPr indent="0" marL="0">
-              <a:buNone/>
-            </a:pPr>
-            <a:r>
-              <a:rPr lang="en-US" sz="1200" b="1" spc="200" kern="0" dirty="0">
+            <a:pPr marL="0" indent="0">
+              <a:buNone/>
+            </a:pPr>
+            <a:r>
+              <a:rPr lang="en-US" sz="1200" b="1" kern="0" spc="200" dirty="0">
                 <a:solidFill>
                   <a:srgbClr val="4F46E5"/>
                 </a:solidFill>
@@ -3374,7 +3234,7 @@
           <a:bodyPr wrap="square" rtlCol="0" anchor="ctr"/>
           <a:lstStyle/>
           <a:p>
-            <a:pPr indent="0" marL="0">
+            <a:pPr marL="0" indent="0">
               <a:buNone/>
             </a:pPr>
             <a:r>
@@ -3418,13 +3278,20 @@
             <a:prstDash val="solid"/>
           </a:ln>
           <a:effectLst>
-            <a:outerShdw sx="100000" sy="100000" kx="0" ky="0" algn="bl" rotWithShape="0" blurRad="101600" dist="25400" dir="5400000">
+            <a:outerShdw blurRad="101600" dist="25400" dir="5400000" algn="bl" rotWithShape="0">
               <a:srgbClr val="B9C2D0">
                 <a:alpha val="35000"/>
               </a:srgbClr>
             </a:outerShdw>
           </a:effectLst>
         </p:spPr>
+        <p:txBody>
+          <a:bodyPr/>
+          <a:lstStyle/>
+          <a:p>
+            <a:endParaRPr lang="en-IN"/>
+          </a:p>
+        </p:txBody>
       </p:sp>
       <p:sp>
         <p:nvSpPr>
@@ -3445,6 +3312,13 @@
           </a:solidFill>
           <a:ln/>
         </p:spPr>
+        <p:txBody>
+          <a:bodyPr/>
+          <a:lstStyle/>
+          <a:p>
+            <a:endParaRPr lang="en-IN"/>
+          </a:p>
+        </p:txBody>
       </p:sp>
       <p:sp>
         <p:nvSpPr>
@@ -3467,7 +3341,7 @@
           <a:bodyPr wrap="square" rtlCol="0" anchor="ctr"/>
           <a:lstStyle/>
           <a:p>
-            <a:pPr algn="ctr" indent="0" marL="0">
+            <a:pPr marL="0" indent="0" algn="ctr">
               <a:buNone/>
             </a:pPr>
             <a:r>
@@ -3506,7 +3380,7 @@
           <a:bodyPr wrap="square" rtlCol="0" anchor="ctr"/>
           <a:lstStyle/>
           <a:p>
-            <a:pPr indent="0" marL="0">
+            <a:pPr marL="0" indent="0">
               <a:buNone/>
             </a:pPr>
             <a:r>
@@ -3545,7 +3419,7 @@
           <a:bodyPr wrap="square" rtlCol="0" anchor="ctr"/>
           <a:lstStyle/>
           <a:p>
-            <a:pPr indent="0" marL="0">
+            <a:pPr marL="0" indent="0">
               <a:buNone/>
             </a:pPr>
             <a:r>
@@ -3589,13 +3463,20 @@
             <a:prstDash val="solid"/>
           </a:ln>
           <a:effectLst>
-            <a:outerShdw sx="100000" sy="100000" kx="0" ky="0" algn="bl" rotWithShape="0" blurRad="101600" dist="25400" dir="5400000">
+            <a:outerShdw blurRad="101600" dist="25400" dir="5400000" algn="bl" rotWithShape="0">
               <a:srgbClr val="B9C2D0">
                 <a:alpha val="35000"/>
               </a:srgbClr>
             </a:outerShdw>
           </a:effectLst>
         </p:spPr>
+        <p:txBody>
+          <a:bodyPr/>
+          <a:lstStyle/>
+          <a:p>
+            <a:endParaRPr lang="en-IN"/>
+          </a:p>
+        </p:txBody>
       </p:sp>
       <p:sp>
         <p:nvSpPr>
@@ -3616,6 +3497,13 @@
           </a:solidFill>
           <a:ln/>
         </p:spPr>
+        <p:txBody>
+          <a:bodyPr/>
+          <a:lstStyle/>
+          <a:p>
+            <a:endParaRPr lang="en-IN"/>
+          </a:p>
+        </p:txBody>
       </p:sp>
       <p:sp>
         <p:nvSpPr>
@@ -3638,7 +3526,7 @@
           <a:bodyPr wrap="square" rtlCol="0" anchor="ctr"/>
           <a:lstStyle/>
           <a:p>
-            <a:pPr algn="ctr" indent="0" marL="0">
+            <a:pPr marL="0" indent="0" algn="ctr">
               <a:buNone/>
             </a:pPr>
             <a:r>
@@ -3677,7 +3565,7 @@
           <a:bodyPr wrap="square" rtlCol="0" anchor="ctr"/>
           <a:lstStyle/>
           <a:p>
-            <a:pPr indent="0" marL="0">
+            <a:pPr marL="0" indent="0">
               <a:buNone/>
             </a:pPr>
             <a:r>
@@ -3716,7 +3604,7 @@
           <a:bodyPr wrap="square" rtlCol="0" anchor="ctr"/>
           <a:lstStyle/>
           <a:p>
-            <a:pPr indent="0" marL="0">
+            <a:pPr marL="0" indent="0">
               <a:buNone/>
             </a:pPr>
             <a:r>
@@ -3760,13 +3648,20 @@
             <a:prstDash val="solid"/>
           </a:ln>
           <a:effectLst>
-            <a:outerShdw sx="100000" sy="100000" kx="0" ky="0" algn="bl" rotWithShape="0" blurRad="101600" dist="25400" dir="5400000">
+            <a:outerShdw blurRad="101600" dist="25400" dir="5400000" algn="bl" rotWithShape="0">
               <a:srgbClr val="B9C2D0">
                 <a:alpha val="35000"/>
               </a:srgbClr>
             </a:outerShdw>
           </a:effectLst>
         </p:spPr>
+        <p:txBody>
+          <a:bodyPr/>
+          <a:lstStyle/>
+          <a:p>
+            <a:endParaRPr lang="en-IN"/>
+          </a:p>
+        </p:txBody>
       </p:sp>
       <p:sp>
         <p:nvSpPr>
@@ -3787,6 +3682,13 @@
           </a:solidFill>
           <a:ln/>
         </p:spPr>
+        <p:txBody>
+          <a:bodyPr/>
+          <a:lstStyle/>
+          <a:p>
+            <a:endParaRPr lang="en-IN"/>
+          </a:p>
+        </p:txBody>
       </p:sp>
       <p:sp>
         <p:nvSpPr>
@@ -3809,7 +3711,7 @@
           <a:bodyPr wrap="square" rtlCol="0" anchor="ctr"/>
           <a:lstStyle/>
           <a:p>
-            <a:pPr algn="ctr" indent="0" marL="0">
+            <a:pPr marL="0" indent="0" algn="ctr">
               <a:buNone/>
             </a:pPr>
             <a:r>
@@ -3848,7 +3750,7 @@
           <a:bodyPr wrap="square" rtlCol="0" anchor="ctr"/>
           <a:lstStyle/>
           <a:p>
-            <a:pPr indent="0" marL="0">
+            <a:pPr marL="0" indent="0">
               <a:buNone/>
             </a:pPr>
             <a:r>
@@ -3887,7 +3789,7 @@
           <a:bodyPr wrap="square" rtlCol="0" anchor="ctr"/>
           <a:lstStyle/>
           <a:p>
-            <a:pPr indent="0" marL="0">
+            <a:pPr marL="0" indent="0">
               <a:buNone/>
             </a:pPr>
             <a:r>
@@ -3931,13 +3833,20 @@
             <a:prstDash val="solid"/>
           </a:ln>
           <a:effectLst>
-            <a:outerShdw sx="100000" sy="100000" kx="0" ky="0" algn="bl" rotWithShape="0" blurRad="101600" dist="25400" dir="5400000">
+            <a:outerShdw blurRad="101600" dist="25400" dir="5400000" algn="bl" rotWithShape="0">
               <a:srgbClr val="B9C2D0">
                 <a:alpha val="35000"/>
               </a:srgbClr>
             </a:outerShdw>
           </a:effectLst>
         </p:spPr>
+        <p:txBody>
+          <a:bodyPr/>
+          <a:lstStyle/>
+          <a:p>
+            <a:endParaRPr lang="en-IN"/>
+          </a:p>
+        </p:txBody>
       </p:sp>
       <p:sp>
         <p:nvSpPr>
@@ -3958,6 +3867,13 @@
           </a:solidFill>
           <a:ln/>
         </p:spPr>
+        <p:txBody>
+          <a:bodyPr/>
+          <a:lstStyle/>
+          <a:p>
+            <a:endParaRPr lang="en-IN"/>
+          </a:p>
+        </p:txBody>
       </p:sp>
       <p:sp>
         <p:nvSpPr>
@@ -3980,7 +3896,7 @@
           <a:bodyPr wrap="square" rtlCol="0" anchor="ctr"/>
           <a:lstStyle/>
           <a:p>
-            <a:pPr algn="ctr" indent="0" marL="0">
+            <a:pPr marL="0" indent="0" algn="ctr">
               <a:buNone/>
             </a:pPr>
             <a:r>
@@ -4019,7 +3935,7 @@
           <a:bodyPr wrap="square" rtlCol="0" anchor="ctr"/>
           <a:lstStyle/>
           <a:p>
-            <a:pPr indent="0" marL="0">
+            <a:pPr marL="0" indent="0">
               <a:buNone/>
             </a:pPr>
             <a:r>
@@ -4058,7 +3974,7 @@
           <a:bodyPr wrap="square" rtlCol="0" anchor="ctr"/>
           <a:lstStyle/>
           <a:p>
-            <a:pPr indent="0" marL="0">
+            <a:pPr marL="0" indent="0">
               <a:buNone/>
             </a:pPr>
             <a:r>
@@ -4095,6 +4011,13 @@
           </a:solidFill>
           <a:ln/>
         </p:spPr>
+        <p:txBody>
+          <a:bodyPr/>
+          <a:lstStyle/>
+          <a:p>
+            <a:endParaRPr lang="en-IN"/>
+          </a:p>
+        </p:txBody>
       </p:sp>
       <p:sp>
         <p:nvSpPr>
@@ -4117,7 +4040,7 @@
           <a:bodyPr wrap="square" rtlCol="0" anchor="ctr"/>
           <a:lstStyle/>
           <a:p>
-            <a:pPr indent="0" marL="0">
+            <a:pPr marL="0" indent="0">
               <a:buNone/>
             </a:pPr>
             <a:r>
@@ -4156,7 +4079,7 @@
           <a:bodyPr wrap="square" rtlCol="0" anchor="ctr"/>
           <a:lstStyle/>
           <a:p>
-            <a:pPr algn="r" indent="0" marL="0">
+            <a:pPr marL="0" indent="0" algn="r">
               <a:buNone/>
             </a:pPr>
             <a:r>
@@ -4190,6 +4113,7 @@
         <a:solidFill>
           <a:srgbClr val="4F46E5"/>
         </a:solidFill>
+        <a:effectLst/>
       </p:bgPr>
     </p:bg>
     <p:spTree>
@@ -4225,6 +4149,13 @@
           </a:solidFill>
           <a:ln/>
         </p:spPr>
+        <p:txBody>
+          <a:bodyPr/>
+          <a:lstStyle/>
+          <a:p>
+            <a:endParaRPr lang="en-IN"/>
+          </a:p>
+        </p:txBody>
       </p:sp>
       <p:sp>
         <p:nvSpPr>
@@ -4247,6 +4178,13 @@
           </a:solidFill>
           <a:ln/>
         </p:spPr>
+        <p:txBody>
+          <a:bodyPr/>
+          <a:lstStyle/>
+          <a:p>
+            <a:endParaRPr lang="en-IN"/>
+          </a:p>
+        </p:txBody>
       </p:sp>
       <p:sp>
         <p:nvSpPr>
@@ -4269,7 +4207,7 @@
           <a:bodyPr wrap="square" rtlCol="0" anchor="ctr"/>
           <a:lstStyle/>
           <a:p>
-            <a:pPr algn="ctr" indent="0" marL="0">
+            <a:pPr marL="0" indent="0" algn="ctr">
               <a:buNone/>
             </a:pPr>
             <a:r>
@@ -4308,7 +4246,7 @@
           <a:bodyPr wrap="square" rtlCol="0" anchor="ctr"/>
           <a:lstStyle/>
           <a:p>
-            <a:pPr indent="0" marL="0">
+            <a:pPr marL="0" indent="0">
               <a:buNone/>
             </a:pPr>
             <a:r>
@@ -4347,7 +4285,7 @@
           <a:bodyPr wrap="square" rtlCol="0" anchor="ctr"/>
           <a:lstStyle/>
           <a:p>
-            <a:pPr indent="0" marL="0">
+            <a:pPr marL="0" indent="0">
               <a:buNone/>
             </a:pPr>
             <a:r>
@@ -4402,7 +4340,7 @@
                 <a:ea typeface="Segoe UI" pitchFamily="34" charset="-122"/>
                 <a:cs typeface="Segoe UI" pitchFamily="34" charset="-120"/>
               </a:rPr>
-              <a:t>Working URL: &lt;your-vercel-url&gt;</a:t>
+              <a:t>Working URL: https://jan-awaaz-ph1fsxk77-l-ai4all.vercel.app/</a:t>
             </a:r>
             <a:endParaRPr lang="en-US" sz="1600" dirty="0"/>
           </a:p>
@@ -4423,7 +4361,40 @@
                 <a:ea typeface="Segoe UI" pitchFamily="34" charset="-122"/>
                 <a:cs typeface="Segoe UI" pitchFamily="34" charset="-120"/>
               </a:rPr>
-              <a:t>GitHub: github.com/lalitsingh-ai/jan-awaaz</a:t>
+              <a:t>GitHub: github.com/</a:t>
+            </a:r>
+            <a:r>
+              <a:rPr lang="en-US" sz="1600" dirty="0" err="1">
+                <a:solidFill>
+                  <a:srgbClr val="EAEEFF"/>
+                </a:solidFill>
+                <a:latin typeface="Segoe UI" pitchFamily="34" charset="0"/>
+                <a:ea typeface="Segoe UI" pitchFamily="34" charset="-122"/>
+                <a:cs typeface="Segoe UI" pitchFamily="34" charset="-120"/>
+              </a:rPr>
+              <a:t>lalitsingh</a:t>
+            </a:r>
+            <a:r>
+              <a:rPr lang="en-US" sz="1600" dirty="0">
+                <a:solidFill>
+                  <a:srgbClr val="EAEEFF"/>
+                </a:solidFill>
+                <a:latin typeface="Segoe UI" pitchFamily="34" charset="0"/>
+                <a:ea typeface="Segoe UI" pitchFamily="34" charset="-122"/>
+                <a:cs typeface="Segoe UI" pitchFamily="34" charset="-120"/>
+              </a:rPr>
+              <a:t>-ai/</a:t>
+            </a:r>
+            <a:r>
+              <a:rPr lang="en-US" sz="1600" dirty="0" err="1">
+                <a:solidFill>
+                  <a:srgbClr val="EAEEFF"/>
+                </a:solidFill>
+                <a:latin typeface="Segoe UI" pitchFamily="34" charset="0"/>
+                <a:ea typeface="Segoe UI" pitchFamily="34" charset="-122"/>
+                <a:cs typeface="Segoe UI" pitchFamily="34" charset="-120"/>
+              </a:rPr>
+              <a:t>jan-awaaz</a:t>
             </a:r>
             <a:endParaRPr lang="en-US" sz="1600" dirty="0"/>
           </a:p>
@@ -4444,7 +4415,29 @@
                 <a:ea typeface="Segoe UI" pitchFamily="34" charset="-122"/>
                 <a:cs typeface="Segoe UI" pitchFamily="34" charset="-120"/>
               </a:rPr>
-              <a:t>Team: &lt;names&gt; · &lt;contact email&gt;</a:t>
+              <a:t>Team: </a:t>
+            </a:r>
+            <a:r>
+              <a:rPr lang="en-US" sz="1600" dirty="0" err="1">
+                <a:solidFill>
+                  <a:srgbClr val="EAEEFF"/>
+                </a:solidFill>
+                <a:latin typeface="Segoe UI" pitchFamily="34" charset="0"/>
+                <a:ea typeface="Segoe UI" pitchFamily="34" charset="-122"/>
+                <a:cs typeface="Segoe UI" pitchFamily="34" charset="-120"/>
+              </a:rPr>
+              <a:t>AI_and_People</a:t>
+            </a:r>
+            <a:r>
+              <a:rPr lang="en-US" sz="1600" dirty="0">
+                <a:solidFill>
+                  <a:srgbClr val="EAEEFF"/>
+                </a:solidFill>
+                <a:latin typeface="Segoe UI" pitchFamily="34" charset="0"/>
+                <a:ea typeface="Segoe UI" pitchFamily="34" charset="-122"/>
+                <a:cs typeface="Segoe UI" pitchFamily="34" charset="-120"/>
+              </a:rPr>
+              <a:t> · &lt;lalitsingh.ai.dev@gmail.com&gt;</a:t>
             </a:r>
             <a:endParaRPr lang="en-US" sz="1600" dirty="0"/>
           </a:p>
@@ -4471,7 +4464,7 @@
           <a:bodyPr wrap="square" rtlCol="0" anchor="ctr"/>
           <a:lstStyle/>
           <a:p>
-            <a:pPr indent="0" marL="0">
+            <a:pPr marL="0" indent="0">
               <a:buNone/>
             </a:pPr>
             <a:r>
@@ -4508,6 +4501,13 @@
           </a:solidFill>
           <a:ln/>
         </p:spPr>
+        <p:txBody>
+          <a:bodyPr/>
+          <a:lstStyle/>
+          <a:p>
+            <a:endParaRPr lang="en-IN"/>
+          </a:p>
+        </p:txBody>
       </p:sp>
       <p:sp>
         <p:nvSpPr>
@@ -4530,7 +4530,7 @@
           <a:bodyPr wrap="square" rtlCol="0" anchor="ctr"/>
           <a:lstStyle/>
           <a:p>
-            <a:pPr indent="0" marL="0">
+            <a:pPr marL="0" indent="0">
               <a:buNone/>
             </a:pPr>
             <a:r>
@@ -4569,7 +4569,7 @@
           <a:bodyPr wrap="square" rtlCol="0" anchor="ctr"/>
           <a:lstStyle/>
           <a:p>
-            <a:pPr algn="r" indent="0" marL="0">
+            <a:pPr marL="0" indent="0" algn="r">
               <a:buNone/>
             </a:pPr>
             <a:r>
@@ -4603,6 +4603,7 @@
         <a:solidFill>
           <a:srgbClr val="F5F7FB"/>
         </a:solidFill>
+        <a:effectLst/>
       </p:bgPr>
     </p:bg>
     <p:spTree>
@@ -4640,11 +4641,11 @@
           <a:bodyPr wrap="square" rtlCol="0" anchor="ctr"/>
           <a:lstStyle/>
           <a:p>
-            <a:pPr indent="0" marL="0">
-              <a:buNone/>
-            </a:pPr>
-            <a:r>
-              <a:rPr lang="en-US" sz="1200" b="1" spc="200" kern="0" dirty="0">
+            <a:pPr marL="0" indent="0">
+              <a:buNone/>
+            </a:pPr>
+            <a:r>
+              <a:rPr lang="en-US" sz="1200" b="1" kern="0" spc="200" dirty="0">
                 <a:solidFill>
                   <a:srgbClr val="4F46E5"/>
                 </a:solidFill>
@@ -4679,7 +4680,7 @@
           <a:bodyPr wrap="square" rtlCol="0" anchor="ctr"/>
           <a:lstStyle/>
           <a:p>
-            <a:pPr indent="0" marL="0">
+            <a:pPr marL="0" indent="0">
               <a:buNone/>
             </a:pPr>
             <a:r>
@@ -4829,13 +4830,20 @@
             <a:prstDash val="solid"/>
           </a:ln>
           <a:effectLst>
-            <a:outerShdw sx="100000" sy="100000" kx="0" ky="0" algn="bl" rotWithShape="0" blurRad="101600" dist="25400" dir="5400000">
+            <a:outerShdw blurRad="101600" dist="25400" dir="5400000" algn="bl" rotWithShape="0">
               <a:srgbClr val="B9C2D0">
                 <a:alpha val="35000"/>
               </a:srgbClr>
             </a:outerShdw>
           </a:effectLst>
         </p:spPr>
+        <p:txBody>
+          <a:bodyPr/>
+          <a:lstStyle/>
+          <a:p>
+            <a:endParaRPr lang="en-IN"/>
+          </a:p>
+        </p:txBody>
       </p:sp>
       <p:sp>
         <p:nvSpPr>
@@ -4858,7 +4866,7 @@
           <a:bodyPr wrap="square" rtlCol="0" anchor="ctr"/>
           <a:lstStyle/>
           <a:p>
-            <a:pPr indent="0" marL="0">
+            <a:pPr marL="0" indent="0">
               <a:buNone/>
             </a:pPr>
             <a:r>
@@ -4897,7 +4905,7 @@
           <a:bodyPr wrap="square" rtlCol="0" anchor="t"/>
           <a:lstStyle/>
           <a:p>
-            <a:pPr indent="0" marL="0">
+            <a:pPr marL="0" indent="0">
               <a:buNone/>
             </a:pPr>
             <a:r>
@@ -4936,7 +4944,7 @@
           <a:bodyPr wrap="square" rtlCol="0" anchor="ctr"/>
           <a:lstStyle/>
           <a:p>
-            <a:pPr indent="0" marL="0">
+            <a:pPr marL="0" indent="0">
               <a:buNone/>
             </a:pPr>
             <a:r>
@@ -4973,6 +4981,13 @@
           </a:solidFill>
           <a:ln/>
         </p:spPr>
+        <p:txBody>
+          <a:bodyPr/>
+          <a:lstStyle/>
+          <a:p>
+            <a:endParaRPr lang="en-IN"/>
+          </a:p>
+        </p:txBody>
       </p:sp>
       <p:sp>
         <p:nvSpPr>
@@ -4995,7 +5010,7 @@
           <a:bodyPr wrap="square" rtlCol="0" anchor="ctr"/>
           <a:lstStyle/>
           <a:p>
-            <a:pPr indent="0" marL="0">
+            <a:pPr marL="0" indent="0">
               <a:buNone/>
             </a:pPr>
             <a:r>
@@ -5034,7 +5049,7 @@
           <a:bodyPr wrap="square" rtlCol="0" anchor="ctr"/>
           <a:lstStyle/>
           <a:p>
-            <a:pPr algn="r" indent="0" marL="0">
+            <a:pPr marL="0" indent="0" algn="r">
               <a:buNone/>
             </a:pPr>
             <a:r>
@@ -5068,6 +5083,7 @@
         <a:solidFill>
           <a:srgbClr val="F5F7FB"/>
         </a:solidFill>
+        <a:effectLst/>
       </p:bgPr>
     </p:bg>
     <p:spTree>
@@ -5105,11 +5121,11 @@
           <a:bodyPr wrap="square" rtlCol="0" anchor="ctr"/>
           <a:lstStyle/>
           <a:p>
-            <a:pPr indent="0" marL="0">
-              <a:buNone/>
-            </a:pPr>
-            <a:r>
-              <a:rPr lang="en-US" sz="1200" b="1" spc="200" kern="0" dirty="0">
+            <a:pPr marL="0" indent="0">
+              <a:buNone/>
+            </a:pPr>
+            <a:r>
+              <a:rPr lang="en-US" sz="1200" b="1" kern="0" spc="200" dirty="0">
                 <a:solidFill>
                   <a:srgbClr val="4F46E5"/>
                 </a:solidFill>
@@ -5144,7 +5160,7 @@
           <a:bodyPr wrap="square" rtlCol="0" anchor="ctr"/>
           <a:lstStyle/>
           <a:p>
-            <a:pPr indent="0" marL="0">
+            <a:pPr marL="0" indent="0">
               <a:buNone/>
             </a:pPr>
             <a:r>
@@ -5188,13 +5204,20 @@
             <a:prstDash val="solid"/>
           </a:ln>
           <a:effectLst>
-            <a:outerShdw sx="100000" sy="100000" kx="0" ky="0" algn="bl" rotWithShape="0" blurRad="101600" dist="25400" dir="5400000">
+            <a:outerShdw blurRad="101600" dist="25400" dir="5400000" algn="bl" rotWithShape="0">
               <a:srgbClr val="B9C2D0">
                 <a:alpha val="35000"/>
               </a:srgbClr>
             </a:outerShdw>
           </a:effectLst>
         </p:spPr>
+        <p:txBody>
+          <a:bodyPr/>
+          <a:lstStyle/>
+          <a:p>
+            <a:endParaRPr lang="en-IN"/>
+          </a:p>
+        </p:txBody>
       </p:sp>
       <p:sp>
         <p:nvSpPr>
@@ -5217,7 +5240,7 @@
           <a:bodyPr wrap="square" rtlCol="0" anchor="ctr"/>
           <a:lstStyle/>
           <a:p>
-            <a:pPr indent="0" marL="0">
+            <a:pPr marL="0" indent="0">
               <a:buNone/>
             </a:pPr>
             <a:r>
@@ -5346,13 +5369,20 @@
             <a:prstDash val="solid"/>
           </a:ln>
           <a:effectLst>
-            <a:outerShdw sx="100000" sy="100000" kx="0" ky="0" algn="bl" rotWithShape="0" blurRad="101600" dist="25400" dir="5400000">
+            <a:outerShdw blurRad="101600" dist="25400" dir="5400000" algn="bl" rotWithShape="0">
               <a:srgbClr val="B9C2D0">
                 <a:alpha val="35000"/>
               </a:srgbClr>
             </a:outerShdw>
           </a:effectLst>
         </p:spPr>
+        <p:txBody>
+          <a:bodyPr/>
+          <a:lstStyle/>
+          <a:p>
+            <a:endParaRPr lang="en-IN"/>
+          </a:p>
+        </p:txBody>
       </p:sp>
       <p:sp>
         <p:nvSpPr>
@@ -5375,7 +5405,7 @@
           <a:bodyPr wrap="square" rtlCol="0" anchor="ctr"/>
           <a:lstStyle/>
           <a:p>
-            <a:pPr indent="0" marL="0">
+            <a:pPr marL="0" indent="0">
               <a:buNone/>
             </a:pPr>
             <a:r>
@@ -5497,6 +5527,13 @@
           </a:solidFill>
           <a:ln/>
         </p:spPr>
+        <p:txBody>
+          <a:bodyPr/>
+          <a:lstStyle/>
+          <a:p>
+            <a:endParaRPr lang="en-IN"/>
+          </a:p>
+        </p:txBody>
       </p:sp>
       <p:sp>
         <p:nvSpPr>
@@ -5519,7 +5556,7 @@
           <a:bodyPr wrap="square" rtlCol="0" anchor="ctr"/>
           <a:lstStyle/>
           <a:p>
-            <a:pPr indent="0" marL="0">
+            <a:pPr marL="0" indent="0">
               <a:buNone/>
             </a:pPr>
             <a:r>
@@ -5558,7 +5595,7 @@
           <a:bodyPr wrap="square" rtlCol="0" anchor="ctr"/>
           <a:lstStyle/>
           <a:p>
-            <a:pPr algn="r" indent="0" marL="0">
+            <a:pPr marL="0" indent="0" algn="r">
               <a:buNone/>
             </a:pPr>
             <a:r>
@@ -5592,6 +5629,7 @@
         <a:solidFill>
           <a:srgbClr val="F5F7FB"/>
         </a:solidFill>
+        <a:effectLst/>
       </p:bgPr>
     </p:bg>
     <p:spTree>
@@ -5629,11 +5667,11 @@
           <a:bodyPr wrap="square" rtlCol="0" anchor="ctr"/>
           <a:lstStyle/>
           <a:p>
-            <a:pPr indent="0" marL="0">
-              <a:buNone/>
-            </a:pPr>
-            <a:r>
-              <a:rPr lang="en-US" sz="1200" b="1" spc="200" kern="0" dirty="0">
+            <a:pPr marL="0" indent="0">
+              <a:buNone/>
+            </a:pPr>
+            <a:r>
+              <a:rPr lang="en-US" sz="1200" b="1" kern="0" spc="200" dirty="0">
                 <a:solidFill>
                   <a:srgbClr val="4F46E5"/>
                 </a:solidFill>
@@ -5668,7 +5706,7 @@
           <a:bodyPr wrap="square" rtlCol="0" anchor="ctr"/>
           <a:lstStyle/>
           <a:p>
-            <a:pPr indent="0" marL="0">
+            <a:pPr marL="0" indent="0">
               <a:buNone/>
             </a:pPr>
             <a:r>
@@ -5712,13 +5750,20 @@
             <a:prstDash val="solid"/>
           </a:ln>
           <a:effectLst>
-            <a:outerShdw sx="100000" sy="100000" kx="0" ky="0" algn="bl" rotWithShape="0" blurRad="101600" dist="25400" dir="5400000">
+            <a:outerShdw blurRad="101600" dist="25400" dir="5400000" algn="bl" rotWithShape="0">
               <a:srgbClr val="B9C2D0">
                 <a:alpha val="35000"/>
               </a:srgbClr>
             </a:outerShdw>
           </a:effectLst>
         </p:spPr>
+        <p:txBody>
+          <a:bodyPr/>
+          <a:lstStyle/>
+          <a:p>
+            <a:endParaRPr lang="en-IN"/>
+          </a:p>
+        </p:txBody>
       </p:sp>
       <p:sp>
         <p:nvSpPr>
@@ -5741,7 +5786,7 @@
           <a:bodyPr wrap="square" rtlCol="0" anchor="ctr"/>
           <a:lstStyle/>
           <a:p>
-            <a:pPr indent="0" marL="0">
+            <a:pPr marL="0" indent="0">
               <a:buNone/>
             </a:pPr>
             <a:r>
@@ -5870,13 +5915,20 @@
             <a:prstDash val="solid"/>
           </a:ln>
           <a:effectLst>
-            <a:outerShdw sx="100000" sy="100000" kx="0" ky="0" algn="bl" rotWithShape="0" blurRad="101600" dist="25400" dir="5400000">
+            <a:outerShdw blurRad="101600" dist="25400" dir="5400000" algn="bl" rotWithShape="0">
               <a:srgbClr val="B9C2D0">
                 <a:alpha val="35000"/>
               </a:srgbClr>
             </a:outerShdw>
           </a:effectLst>
         </p:spPr>
+        <p:txBody>
+          <a:bodyPr/>
+          <a:lstStyle/>
+          <a:p>
+            <a:endParaRPr lang="en-IN"/>
+          </a:p>
+        </p:txBody>
       </p:sp>
       <p:sp>
         <p:nvSpPr>
@@ -5899,7 +5951,7 @@
           <a:bodyPr wrap="square" rtlCol="0" anchor="ctr"/>
           <a:lstStyle/>
           <a:p>
-            <a:pPr indent="0" marL="0">
+            <a:pPr marL="0" indent="0">
               <a:buNone/>
             </a:pPr>
             <a:r>
@@ -5938,7 +5990,7 @@
           <a:bodyPr wrap="square" rtlCol="0" anchor="ctr"/>
           <a:lstStyle/>
           <a:p>
-            <a:pPr indent="0" marL="0">
+            <a:pPr marL="0" indent="0">
               <a:buNone/>
             </a:pPr>
             <a:r>
@@ -5977,6 +6029,13 @@
           </a:solidFill>
           <a:ln/>
         </p:spPr>
+        <p:txBody>
+          <a:bodyPr/>
+          <a:lstStyle/>
+          <a:p>
+            <a:endParaRPr lang="en-IN"/>
+          </a:p>
+        </p:txBody>
       </p:sp>
       <p:sp>
         <p:nvSpPr>
@@ -5999,6 +6058,13 @@
           </a:solidFill>
           <a:ln/>
         </p:spPr>
+        <p:txBody>
+          <a:bodyPr/>
+          <a:lstStyle/>
+          <a:p>
+            <a:endParaRPr lang="en-IN"/>
+          </a:p>
+        </p:txBody>
       </p:sp>
       <p:sp>
         <p:nvSpPr>
@@ -6021,7 +6087,7 @@
           <a:bodyPr wrap="square" rtlCol="0" anchor="ctr"/>
           <a:lstStyle/>
           <a:p>
-            <a:pPr indent="0" marL="0">
+            <a:pPr marL="0" indent="0">
               <a:buNone/>
             </a:pPr>
             <a:r>
@@ -6060,6 +6126,13 @@
           </a:solidFill>
           <a:ln/>
         </p:spPr>
+        <p:txBody>
+          <a:bodyPr/>
+          <a:lstStyle/>
+          <a:p>
+            <a:endParaRPr lang="en-IN"/>
+          </a:p>
+        </p:txBody>
       </p:sp>
       <p:sp>
         <p:nvSpPr>
@@ -6082,6 +6155,13 @@
           </a:solidFill>
           <a:ln/>
         </p:spPr>
+        <p:txBody>
+          <a:bodyPr/>
+          <a:lstStyle/>
+          <a:p>
+            <a:endParaRPr lang="en-IN"/>
+          </a:p>
+        </p:txBody>
       </p:sp>
       <p:sp>
         <p:nvSpPr>
@@ -6104,7 +6184,7 @@
           <a:bodyPr wrap="square" rtlCol="0" anchor="ctr"/>
           <a:lstStyle/>
           <a:p>
-            <a:pPr indent="0" marL="0">
+            <a:pPr marL="0" indent="0">
               <a:buNone/>
             </a:pPr>
             <a:r>
@@ -6143,6 +6223,13 @@
           </a:solidFill>
           <a:ln/>
         </p:spPr>
+        <p:txBody>
+          <a:bodyPr/>
+          <a:lstStyle/>
+          <a:p>
+            <a:endParaRPr lang="en-IN"/>
+          </a:p>
+        </p:txBody>
       </p:sp>
       <p:sp>
         <p:nvSpPr>
@@ -6165,6 +6252,13 @@
           </a:solidFill>
           <a:ln/>
         </p:spPr>
+        <p:txBody>
+          <a:bodyPr/>
+          <a:lstStyle/>
+          <a:p>
+            <a:endParaRPr lang="en-IN"/>
+          </a:p>
+        </p:txBody>
       </p:sp>
       <p:sp>
         <p:nvSpPr>
@@ -6187,7 +6281,7 @@
           <a:bodyPr wrap="square" rtlCol="0" anchor="ctr"/>
           <a:lstStyle/>
           <a:p>
-            <a:pPr indent="0" marL="0">
+            <a:pPr marL="0" indent="0">
               <a:buNone/>
             </a:pPr>
             <a:r>
@@ -6226,6 +6320,13 @@
           </a:solidFill>
           <a:ln/>
         </p:spPr>
+        <p:txBody>
+          <a:bodyPr/>
+          <a:lstStyle/>
+          <a:p>
+            <a:endParaRPr lang="en-IN"/>
+          </a:p>
+        </p:txBody>
       </p:sp>
       <p:sp>
         <p:nvSpPr>
@@ -6248,6 +6349,13 @@
           </a:solidFill>
           <a:ln/>
         </p:spPr>
+        <p:txBody>
+          <a:bodyPr/>
+          <a:lstStyle/>
+          <a:p>
+            <a:endParaRPr lang="en-IN"/>
+          </a:p>
+        </p:txBody>
       </p:sp>
       <p:sp>
         <p:nvSpPr>
@@ -6270,7 +6378,7 @@
           <a:bodyPr wrap="square" rtlCol="0" anchor="ctr"/>
           <a:lstStyle/>
           <a:p>
-            <a:pPr indent="0" marL="0">
+            <a:pPr marL="0" indent="0">
               <a:buNone/>
             </a:pPr>
             <a:r>
@@ -6307,6 +6415,13 @@
           </a:solidFill>
           <a:ln/>
         </p:spPr>
+        <p:txBody>
+          <a:bodyPr/>
+          <a:lstStyle/>
+          <a:p>
+            <a:endParaRPr lang="en-IN"/>
+          </a:p>
+        </p:txBody>
       </p:sp>
       <p:sp>
         <p:nvSpPr>
@@ -6329,7 +6444,7 @@
           <a:bodyPr wrap="square" rtlCol="0" anchor="ctr"/>
           <a:lstStyle/>
           <a:p>
-            <a:pPr indent="0" marL="0">
+            <a:pPr marL="0" indent="0">
               <a:buNone/>
             </a:pPr>
             <a:r>
@@ -6368,7 +6483,7 @@
           <a:bodyPr wrap="square" rtlCol="0" anchor="ctr"/>
           <a:lstStyle/>
           <a:p>
-            <a:pPr algn="r" indent="0" marL="0">
+            <a:pPr marL="0" indent="0" algn="r">
               <a:buNone/>
             </a:pPr>
             <a:r>
@@ -6402,6 +6517,7 @@
         <a:solidFill>
           <a:srgbClr val="F5F7FB"/>
         </a:solidFill>
+        <a:effectLst/>
       </p:bgPr>
     </p:bg>
     <p:spTree>
@@ -6439,11 +6555,11 @@
           <a:bodyPr wrap="square" rtlCol="0" anchor="ctr"/>
           <a:lstStyle/>
           <a:p>
-            <a:pPr indent="0" marL="0">
-              <a:buNone/>
-            </a:pPr>
-            <a:r>
-              <a:rPr lang="en-US" sz="1200" b="1" spc="200" kern="0" dirty="0">
+            <a:pPr marL="0" indent="0">
+              <a:buNone/>
+            </a:pPr>
+            <a:r>
+              <a:rPr lang="en-US" sz="1200" b="1" kern="0" spc="200" dirty="0">
                 <a:solidFill>
                   <a:srgbClr val="4F46E5"/>
                 </a:solidFill>
@@ -6478,7 +6594,7 @@
           <a:bodyPr wrap="square" rtlCol="0" anchor="ctr"/>
           <a:lstStyle/>
           <a:p>
-            <a:pPr indent="0" marL="0">
+            <a:pPr marL="0" indent="0">
               <a:buNone/>
             </a:pPr>
             <a:r>
@@ -6522,6 +6638,13 @@
             <a:prstDash val="solid"/>
           </a:ln>
         </p:spPr>
+        <p:txBody>
+          <a:bodyPr/>
+          <a:lstStyle/>
+          <a:p>
+            <a:endParaRPr lang="en-IN"/>
+          </a:p>
+        </p:txBody>
       </p:sp>
       <p:sp>
         <p:nvSpPr>
@@ -6542,6 +6665,13 @@
           </a:solidFill>
           <a:ln/>
         </p:spPr>
+        <p:txBody>
+          <a:bodyPr/>
+          <a:lstStyle/>
+          <a:p>
+            <a:endParaRPr lang="en-IN"/>
+          </a:p>
+        </p:txBody>
       </p:sp>
       <p:sp>
         <p:nvSpPr>
@@ -6564,7 +6694,7 @@
           <a:bodyPr wrap="square" rtlCol="0" anchor="ctr"/>
           <a:lstStyle/>
           <a:p>
-            <a:pPr indent="0" marL="0">
+            <a:pPr marL="0" indent="0">
               <a:buNone/>
             </a:pPr>
             <a:r>
@@ -6603,7 +6733,7 @@
           <a:bodyPr wrap="square" rtlCol="0" anchor="t"/>
           <a:lstStyle/>
           <a:p>
-            <a:pPr indent="0" marL="0">
+            <a:pPr marL="0" indent="0">
               <a:buNone/>
             </a:pPr>
             <a:r>
@@ -6620,7 +6750,7 @@
             <a:endParaRPr lang="en-US" sz="1100" dirty="0"/>
           </a:p>
           <a:p>
-            <a:pPr indent="0" marL="0">
+            <a:pPr marL="0" indent="0">
               <a:buNone/>
             </a:pPr>
             <a:r>
@@ -6637,7 +6767,7 @@
             <a:endParaRPr lang="en-US" sz="1100" dirty="0"/>
           </a:p>
           <a:p>
-            <a:pPr indent="0" marL="0">
+            <a:pPr marL="0" indent="0">
               <a:buNone/>
             </a:pPr>
             <a:r>
@@ -6681,6 +6811,13 @@
             <a:prstDash val="solid"/>
           </a:ln>
         </p:spPr>
+        <p:txBody>
+          <a:bodyPr/>
+          <a:lstStyle/>
+          <a:p>
+            <a:endParaRPr lang="en-IN"/>
+          </a:p>
+        </p:txBody>
       </p:sp>
       <p:sp>
         <p:nvSpPr>
@@ -6701,6 +6838,13 @@
           </a:solidFill>
           <a:ln/>
         </p:spPr>
+        <p:txBody>
+          <a:bodyPr/>
+          <a:lstStyle/>
+          <a:p>
+            <a:endParaRPr lang="en-IN"/>
+          </a:p>
+        </p:txBody>
       </p:sp>
       <p:sp>
         <p:nvSpPr>
@@ -6723,7 +6867,7 @@
           <a:bodyPr wrap="square" rtlCol="0" anchor="ctr"/>
           <a:lstStyle/>
           <a:p>
-            <a:pPr indent="0" marL="0">
+            <a:pPr marL="0" indent="0">
               <a:buNone/>
             </a:pPr>
             <a:r>
@@ -6762,7 +6906,7 @@
           <a:bodyPr wrap="square" rtlCol="0" anchor="t"/>
           <a:lstStyle/>
           <a:p>
-            <a:pPr indent="0" marL="0">
+            <a:pPr marL="0" indent="0">
               <a:buNone/>
             </a:pPr>
             <a:r>
@@ -6779,7 +6923,7 @@
             <a:endParaRPr lang="en-US" sz="1100" dirty="0"/>
           </a:p>
           <a:p>
-            <a:pPr indent="0" marL="0">
+            <a:pPr marL="0" indent="0">
               <a:buNone/>
             </a:pPr>
             <a:r>
@@ -6796,7 +6940,7 @@
             <a:endParaRPr lang="en-US" sz="1100" dirty="0"/>
           </a:p>
           <a:p>
-            <a:pPr indent="0" marL="0">
+            <a:pPr marL="0" indent="0">
               <a:buNone/>
             </a:pPr>
             <a:r>
@@ -6840,6 +6984,13 @@
             <a:prstDash val="solid"/>
           </a:ln>
         </p:spPr>
+        <p:txBody>
+          <a:bodyPr/>
+          <a:lstStyle/>
+          <a:p>
+            <a:endParaRPr lang="en-IN"/>
+          </a:p>
+        </p:txBody>
       </p:sp>
       <p:sp>
         <p:nvSpPr>
@@ -6860,6 +7011,13 @@
           </a:solidFill>
           <a:ln/>
         </p:spPr>
+        <p:txBody>
+          <a:bodyPr/>
+          <a:lstStyle/>
+          <a:p>
+            <a:endParaRPr lang="en-IN"/>
+          </a:p>
+        </p:txBody>
       </p:sp>
       <p:sp>
         <p:nvSpPr>
@@ -6882,7 +7040,7 @@
           <a:bodyPr wrap="square" rtlCol="0" anchor="ctr"/>
           <a:lstStyle/>
           <a:p>
-            <a:pPr indent="0" marL="0">
+            <a:pPr marL="0" indent="0">
               <a:buNone/>
             </a:pPr>
             <a:r>
@@ -6921,7 +7079,7 @@
           <a:bodyPr wrap="square" rtlCol="0" anchor="t"/>
           <a:lstStyle/>
           <a:p>
-            <a:pPr indent="0" marL="0">
+            <a:pPr marL="0" indent="0">
               <a:buNone/>
             </a:pPr>
             <a:r>
@@ -6938,7 +7096,7 @@
             <a:endParaRPr lang="en-US" sz="1100" dirty="0"/>
           </a:p>
           <a:p>
-            <a:pPr indent="0" marL="0">
+            <a:pPr marL="0" indent="0">
               <a:buNone/>
             </a:pPr>
             <a:r>
@@ -6955,7 +7113,7 @@
             <a:endParaRPr lang="en-US" sz="1100" dirty="0"/>
           </a:p>
           <a:p>
-            <a:pPr indent="0" marL="0">
+            <a:pPr marL="0" indent="0">
               <a:buNone/>
             </a:pPr>
             <a:r>
@@ -6992,6 +7150,13 @@
           </a:solidFill>
           <a:ln/>
         </p:spPr>
+        <p:txBody>
+          <a:bodyPr/>
+          <a:lstStyle/>
+          <a:p>
+            <a:endParaRPr lang="en-IN"/>
+          </a:p>
+        </p:txBody>
       </p:sp>
       <p:sp>
         <p:nvSpPr>
@@ -7012,6 +7177,13 @@
           </a:solidFill>
           <a:ln/>
         </p:spPr>
+        <p:txBody>
+          <a:bodyPr/>
+          <a:lstStyle/>
+          <a:p>
+            <a:endParaRPr lang="en-IN"/>
+          </a:p>
+        </p:txBody>
       </p:sp>
       <p:sp>
         <p:nvSpPr>
@@ -7039,13 +7211,20 @@
             <a:prstDash val="solid"/>
           </a:ln>
           <a:effectLst>
-            <a:outerShdw sx="100000" sy="100000" kx="0" ky="0" algn="bl" rotWithShape="0" blurRad="101600" dist="25400" dir="5400000">
+            <a:outerShdw blurRad="101600" dist="25400" dir="5400000" algn="bl" rotWithShape="0">
               <a:srgbClr val="B9C2D0">
                 <a:alpha val="35000"/>
               </a:srgbClr>
             </a:outerShdw>
           </a:effectLst>
         </p:spPr>
+        <p:txBody>
+          <a:bodyPr/>
+          <a:lstStyle/>
+          <a:p>
+            <a:endParaRPr lang="en-IN"/>
+          </a:p>
+        </p:txBody>
       </p:sp>
       <p:sp>
         <p:nvSpPr>
@@ -7068,7 +7247,7 @@
           <a:bodyPr wrap="square" rtlCol="0" anchor="ctr"/>
           <a:lstStyle/>
           <a:p>
-            <a:pPr indent="0" marL="0">
+            <a:pPr marL="0" indent="0">
               <a:buNone/>
             </a:pPr>
             <a:r>
@@ -7107,7 +7286,7 @@
           <a:bodyPr wrap="square" rtlCol="0" anchor="ctr"/>
           <a:lstStyle/>
           <a:p>
-            <a:pPr indent="0" marL="0">
+            <a:pPr marL="0" indent="0">
               <a:buNone/>
             </a:pPr>
             <a:r>
@@ -7144,6 +7323,13 @@
           </a:solidFill>
           <a:ln/>
         </p:spPr>
+        <p:txBody>
+          <a:bodyPr/>
+          <a:lstStyle/>
+          <a:p>
+            <a:endParaRPr lang="en-IN"/>
+          </a:p>
+        </p:txBody>
       </p:sp>
       <p:sp>
         <p:nvSpPr>
@@ -7166,7 +7352,7 @@
           <a:bodyPr wrap="square" rtlCol="0" anchor="ctr"/>
           <a:lstStyle/>
           <a:p>
-            <a:pPr indent="0" marL="0">
+            <a:pPr marL="0" indent="0">
               <a:buNone/>
             </a:pPr>
             <a:r>
@@ -7205,7 +7391,7 @@
           <a:bodyPr wrap="square" rtlCol="0" anchor="ctr"/>
           <a:lstStyle/>
           <a:p>
-            <a:pPr algn="r" indent="0" marL="0">
+            <a:pPr marL="0" indent="0" algn="r">
               <a:buNone/>
             </a:pPr>
             <a:r>
@@ -7239,6 +7425,7 @@
         <a:solidFill>
           <a:srgbClr val="0F172A"/>
         </a:solidFill>
+        <a:effectLst/>
       </p:bgPr>
     </p:bg>
     <p:spTree>
@@ -7276,11 +7463,11 @@
           <a:bodyPr wrap="square" rtlCol="0" anchor="ctr"/>
           <a:lstStyle/>
           <a:p>
-            <a:pPr indent="0" marL="0">
-              <a:buNone/>
-            </a:pPr>
-            <a:r>
-              <a:rPr lang="en-US" sz="1200" b="1" spc="200" kern="0" dirty="0">
+            <a:pPr marL="0" indent="0">
+              <a:buNone/>
+            </a:pPr>
+            <a:r>
+              <a:rPr lang="en-US" sz="1200" b="1" kern="0" spc="200" dirty="0">
                 <a:solidFill>
                   <a:srgbClr val="8B96FF"/>
                 </a:solidFill>
@@ -7315,7 +7502,7 @@
           <a:bodyPr wrap="square" rtlCol="0" anchor="ctr"/>
           <a:lstStyle/>
           <a:p>
-            <a:pPr indent="0" marL="0">
+            <a:pPr marL="0" indent="0">
               <a:buNone/>
             </a:pPr>
             <a:r>
@@ -7352,6 +7539,13 @@
           </a:solidFill>
           <a:ln/>
         </p:spPr>
+        <p:txBody>
+          <a:bodyPr/>
+          <a:lstStyle/>
+          <a:p>
+            <a:endParaRPr lang="en-IN"/>
+          </a:p>
+        </p:txBody>
       </p:sp>
       <p:sp>
         <p:nvSpPr>
@@ -7374,7 +7568,7 @@
           <a:bodyPr wrap="square" rtlCol="0" anchor="ctr"/>
           <a:lstStyle/>
           <a:p>
-            <a:pPr algn="ctr" indent="0" marL="0">
+            <a:pPr marL="0" indent="0" algn="ctr">
               <a:buNone/>
             </a:pPr>
             <a:r>
@@ -7413,7 +7607,7 @@
           <a:bodyPr wrap="square" rtlCol="0" anchor="ctr"/>
           <a:lstStyle/>
           <a:p>
-            <a:pPr indent="0" marL="0">
+            <a:pPr marL="0" indent="0">
               <a:buNone/>
             </a:pPr>
             <a:r>
@@ -7452,7 +7646,7 @@
           <a:bodyPr wrap="square" rtlCol="0" anchor="ctr"/>
           <a:lstStyle/>
           <a:p>
-            <a:pPr indent="0" marL="0">
+            <a:pPr marL="0" indent="0">
               <a:buNone/>
             </a:pPr>
             <a:r>
@@ -7489,6 +7683,13 @@
           </a:solidFill>
           <a:ln/>
         </p:spPr>
+        <p:txBody>
+          <a:bodyPr/>
+          <a:lstStyle/>
+          <a:p>
+            <a:endParaRPr lang="en-IN"/>
+          </a:p>
+        </p:txBody>
       </p:sp>
       <p:sp>
         <p:nvSpPr>
@@ -7511,7 +7712,7 @@
           <a:bodyPr wrap="square" rtlCol="0" anchor="ctr"/>
           <a:lstStyle/>
           <a:p>
-            <a:pPr algn="ctr" indent="0" marL="0">
+            <a:pPr marL="0" indent="0" algn="ctr">
               <a:buNone/>
             </a:pPr>
             <a:r>
@@ -7550,7 +7751,7 @@
           <a:bodyPr wrap="square" rtlCol="0" anchor="ctr"/>
           <a:lstStyle/>
           <a:p>
-            <a:pPr indent="0" marL="0">
+            <a:pPr marL="0" indent="0">
               <a:buNone/>
             </a:pPr>
             <a:r>
@@ -7589,7 +7790,7 @@
           <a:bodyPr wrap="square" rtlCol="0" anchor="ctr"/>
           <a:lstStyle/>
           <a:p>
-            <a:pPr indent="0" marL="0">
+            <a:pPr marL="0" indent="0">
               <a:buNone/>
             </a:pPr>
             <a:r>
@@ -7626,6 +7827,13 @@
           </a:solidFill>
           <a:ln/>
         </p:spPr>
+        <p:txBody>
+          <a:bodyPr/>
+          <a:lstStyle/>
+          <a:p>
+            <a:endParaRPr lang="en-IN"/>
+          </a:p>
+        </p:txBody>
       </p:sp>
       <p:sp>
         <p:nvSpPr>
@@ -7648,7 +7856,7 @@
           <a:bodyPr wrap="square" rtlCol="0" anchor="ctr"/>
           <a:lstStyle/>
           <a:p>
-            <a:pPr algn="ctr" indent="0" marL="0">
+            <a:pPr marL="0" indent="0" algn="ctr">
               <a:buNone/>
             </a:pPr>
             <a:r>
@@ -7687,7 +7895,7 @@
           <a:bodyPr wrap="square" rtlCol="0" anchor="ctr"/>
           <a:lstStyle/>
           <a:p>
-            <a:pPr indent="0" marL="0">
+            <a:pPr marL="0" indent="0">
               <a:buNone/>
             </a:pPr>
             <a:r>
@@ -7726,7 +7934,7 @@
           <a:bodyPr wrap="square" rtlCol="0" anchor="ctr"/>
           <a:lstStyle/>
           <a:p>
-            <a:pPr indent="0" marL="0">
+            <a:pPr marL="0" indent="0">
               <a:buNone/>
             </a:pPr>
             <a:r>
@@ -7765,7 +7973,7 @@
           <a:bodyPr wrap="square" rtlCol="0" anchor="ctr"/>
           <a:lstStyle/>
           <a:p>
-            <a:pPr indent="0" marL="0">
+            <a:pPr marL="0" indent="0">
               <a:buNone/>
             </a:pPr>
             <a:r>
@@ -7802,6 +8010,13 @@
           </a:solidFill>
           <a:ln/>
         </p:spPr>
+        <p:txBody>
+          <a:bodyPr/>
+          <a:lstStyle/>
+          <a:p>
+            <a:endParaRPr lang="en-IN"/>
+          </a:p>
+        </p:txBody>
       </p:sp>
       <p:sp>
         <p:nvSpPr>
@@ -7824,7 +8039,7 @@
           <a:bodyPr wrap="square" rtlCol="0" anchor="ctr"/>
           <a:lstStyle/>
           <a:p>
-            <a:pPr indent="0" marL="0">
+            <a:pPr marL="0" indent="0">
               <a:buNone/>
             </a:pPr>
             <a:r>
@@ -7863,7 +8078,7 @@
           <a:bodyPr wrap="square" rtlCol="0" anchor="ctr"/>
           <a:lstStyle/>
           <a:p>
-            <a:pPr algn="r" indent="0" marL="0">
+            <a:pPr marL="0" indent="0" algn="r">
               <a:buNone/>
             </a:pPr>
             <a:r>
@@ -7897,6 +8112,7 @@
         <a:solidFill>
           <a:srgbClr val="F5F7FB"/>
         </a:solidFill>
+        <a:effectLst/>
       </p:bgPr>
     </p:bg>
     <p:spTree>
@@ -7934,11 +8150,11 @@
           <a:bodyPr wrap="square" rtlCol="0" anchor="ctr"/>
           <a:lstStyle/>
           <a:p>
-            <a:pPr indent="0" marL="0">
-              <a:buNone/>
-            </a:pPr>
-            <a:r>
-              <a:rPr lang="en-US" sz="1200" b="1" spc="200" kern="0" dirty="0">
+            <a:pPr marL="0" indent="0">
+              <a:buNone/>
+            </a:pPr>
+            <a:r>
+              <a:rPr lang="en-US" sz="1200" b="1" kern="0" spc="200" dirty="0">
                 <a:solidFill>
                   <a:srgbClr val="4F46E5"/>
                 </a:solidFill>
@@ -7973,7 +8189,7 @@
           <a:bodyPr wrap="square" rtlCol="0" anchor="ctr"/>
           <a:lstStyle/>
           <a:p>
-            <a:pPr indent="0" marL="0">
+            <a:pPr marL="0" indent="0">
               <a:buNone/>
             </a:pPr>
             <a:r>
@@ -8017,13 +8233,20 @@
             <a:prstDash val="solid"/>
           </a:ln>
           <a:effectLst>
-            <a:outerShdw sx="100000" sy="100000" kx="0" ky="0" algn="bl" rotWithShape="0" blurRad="101600" dist="25400" dir="5400000">
+            <a:outerShdw blurRad="101600" dist="25400" dir="5400000" algn="bl" rotWithShape="0">
               <a:srgbClr val="B9C2D0">
                 <a:alpha val="35000"/>
               </a:srgbClr>
             </a:outerShdw>
           </a:effectLst>
         </p:spPr>
+        <p:txBody>
+          <a:bodyPr/>
+          <a:lstStyle/>
+          <a:p>
+            <a:endParaRPr lang="en-IN"/>
+          </a:p>
+        </p:txBody>
       </p:sp>
       <p:sp>
         <p:nvSpPr>
@@ -8046,7 +8269,7 @@
           <a:bodyPr wrap="square" rtlCol="0" anchor="ctr"/>
           <a:lstStyle/>
           <a:p>
-            <a:pPr algn="ctr" indent="0" marL="0">
+            <a:pPr marL="0" indent="0" algn="ctr">
               <a:buNone/>
             </a:pPr>
             <a:r>
@@ -8085,7 +8308,7 @@
           <a:bodyPr wrap="square" rtlCol="0" anchor="ctr"/>
           <a:lstStyle/>
           <a:p>
-            <a:pPr indent="0" marL="0">
+            <a:pPr marL="0" indent="0">
               <a:buNone/>
             </a:pPr>
             <a:r>
@@ -8124,7 +8347,7 @@
           <a:bodyPr wrap="square" rtlCol="0" anchor="t"/>
           <a:lstStyle/>
           <a:p>
-            <a:pPr indent="0" marL="0">
+            <a:pPr marL="0" indent="0">
               <a:buNone/>
             </a:pPr>
             <a:r>
@@ -8168,13 +8391,20 @@
             <a:prstDash val="solid"/>
           </a:ln>
           <a:effectLst>
-            <a:outerShdw sx="100000" sy="100000" kx="0" ky="0" algn="bl" rotWithShape="0" blurRad="101600" dist="25400" dir="5400000">
+            <a:outerShdw blurRad="101600" dist="25400" dir="5400000" algn="bl" rotWithShape="0">
               <a:srgbClr val="B9C2D0">
                 <a:alpha val="35000"/>
               </a:srgbClr>
             </a:outerShdw>
           </a:effectLst>
         </p:spPr>
+        <p:txBody>
+          <a:bodyPr/>
+          <a:lstStyle/>
+          <a:p>
+            <a:endParaRPr lang="en-IN"/>
+          </a:p>
+        </p:txBody>
       </p:sp>
       <p:sp>
         <p:nvSpPr>
@@ -8197,7 +8427,7 @@
           <a:bodyPr wrap="square" rtlCol="0" anchor="ctr"/>
           <a:lstStyle/>
           <a:p>
-            <a:pPr algn="ctr" indent="0" marL="0">
+            <a:pPr marL="0" indent="0" algn="ctr">
               <a:buNone/>
             </a:pPr>
             <a:r>
@@ -8236,7 +8466,7 @@
           <a:bodyPr wrap="square" rtlCol="0" anchor="ctr"/>
           <a:lstStyle/>
           <a:p>
-            <a:pPr indent="0" marL="0">
+            <a:pPr marL="0" indent="0">
               <a:buNone/>
             </a:pPr>
             <a:r>
@@ -8275,7 +8505,7 @@
           <a:bodyPr wrap="square" rtlCol="0" anchor="t"/>
           <a:lstStyle/>
           <a:p>
-            <a:pPr indent="0" marL="0">
+            <a:pPr marL="0" indent="0">
               <a:buNone/>
             </a:pPr>
             <a:r>
@@ -8319,13 +8549,20 @@
             <a:prstDash val="solid"/>
           </a:ln>
           <a:effectLst>
-            <a:outerShdw sx="100000" sy="100000" kx="0" ky="0" algn="bl" rotWithShape="0" blurRad="101600" dist="25400" dir="5400000">
+            <a:outerShdw blurRad="101600" dist="25400" dir="5400000" algn="bl" rotWithShape="0">
               <a:srgbClr val="B9C2D0">
                 <a:alpha val="35000"/>
               </a:srgbClr>
             </a:outerShdw>
           </a:effectLst>
         </p:spPr>
+        <p:txBody>
+          <a:bodyPr/>
+          <a:lstStyle/>
+          <a:p>
+            <a:endParaRPr lang="en-IN"/>
+          </a:p>
+        </p:txBody>
       </p:sp>
       <p:sp>
         <p:nvSpPr>
@@ -8348,7 +8585,7 @@
           <a:bodyPr wrap="square" rtlCol="0" anchor="ctr"/>
           <a:lstStyle/>
           <a:p>
-            <a:pPr algn="ctr" indent="0" marL="0">
+            <a:pPr marL="0" indent="0" algn="ctr">
               <a:buNone/>
             </a:pPr>
             <a:r>
@@ -8387,7 +8624,7 @@
           <a:bodyPr wrap="square" rtlCol="0" anchor="ctr"/>
           <a:lstStyle/>
           <a:p>
-            <a:pPr indent="0" marL="0">
+            <a:pPr marL="0" indent="0">
               <a:buNone/>
             </a:pPr>
             <a:r>
@@ -8426,7 +8663,7 @@
           <a:bodyPr wrap="square" rtlCol="0" anchor="t"/>
           <a:lstStyle/>
           <a:p>
-            <a:pPr indent="0" marL="0">
+            <a:pPr marL="0" indent="0">
               <a:buNone/>
             </a:pPr>
             <a:r>
@@ -8470,13 +8707,20 @@
             <a:prstDash val="solid"/>
           </a:ln>
           <a:effectLst>
-            <a:outerShdw sx="100000" sy="100000" kx="0" ky="0" algn="bl" rotWithShape="0" blurRad="101600" dist="25400" dir="5400000">
+            <a:outerShdw blurRad="101600" dist="25400" dir="5400000" algn="bl" rotWithShape="0">
               <a:srgbClr val="B9C2D0">
                 <a:alpha val="35000"/>
               </a:srgbClr>
             </a:outerShdw>
           </a:effectLst>
         </p:spPr>
+        <p:txBody>
+          <a:bodyPr/>
+          <a:lstStyle/>
+          <a:p>
+            <a:endParaRPr lang="en-IN"/>
+          </a:p>
+        </p:txBody>
       </p:sp>
       <p:sp>
         <p:nvSpPr>
@@ -8499,7 +8743,7 @@
           <a:bodyPr wrap="square" rtlCol="0" anchor="ctr"/>
           <a:lstStyle/>
           <a:p>
-            <a:pPr algn="ctr" indent="0" marL="0">
+            <a:pPr marL="0" indent="0" algn="ctr">
               <a:buNone/>
             </a:pPr>
             <a:r>
@@ -8538,7 +8782,7 @@
           <a:bodyPr wrap="square" rtlCol="0" anchor="ctr"/>
           <a:lstStyle/>
           <a:p>
-            <a:pPr indent="0" marL="0">
+            <a:pPr marL="0" indent="0">
               <a:buNone/>
             </a:pPr>
             <a:r>
@@ -8577,7 +8821,7 @@
           <a:bodyPr wrap="square" rtlCol="0" anchor="t"/>
           <a:lstStyle/>
           <a:p>
-            <a:pPr indent="0" marL="0">
+            <a:pPr marL="0" indent="0">
               <a:buNone/>
             </a:pPr>
             <a:r>
@@ -8614,6 +8858,13 @@
           </a:solidFill>
           <a:ln/>
         </p:spPr>
+        <p:txBody>
+          <a:bodyPr/>
+          <a:lstStyle/>
+          <a:p>
+            <a:endParaRPr lang="en-IN"/>
+          </a:p>
+        </p:txBody>
       </p:sp>
       <p:sp>
         <p:nvSpPr>
@@ -8636,7 +8887,7 @@
           <a:bodyPr wrap="square" rtlCol="0" anchor="ctr"/>
           <a:lstStyle/>
           <a:p>
-            <a:pPr indent="0" marL="0">
+            <a:pPr marL="0" indent="0">
               <a:buNone/>
             </a:pPr>
             <a:r>
@@ -8675,7 +8926,7 @@
           <a:bodyPr wrap="square" rtlCol="0" anchor="ctr"/>
           <a:lstStyle/>
           <a:p>
-            <a:pPr algn="r" indent="0" marL="0">
+            <a:pPr marL="0" indent="0" algn="r">
               <a:buNone/>
             </a:pPr>
             <a:r>
@@ -8709,6 +8960,7 @@
         <a:solidFill>
           <a:srgbClr val="F5F7FB"/>
         </a:solidFill>
+        <a:effectLst/>
       </p:bgPr>
     </p:bg>
     <p:spTree>
@@ -8746,11 +8998,11 @@
           <a:bodyPr wrap="square" rtlCol="0" anchor="ctr"/>
           <a:lstStyle/>
           <a:p>
-            <a:pPr indent="0" marL="0">
-              <a:buNone/>
-            </a:pPr>
-            <a:r>
-              <a:rPr lang="en-US" sz="1200" b="1" spc="200" kern="0" dirty="0">
+            <a:pPr marL="0" indent="0">
+              <a:buNone/>
+            </a:pPr>
+            <a:r>
+              <a:rPr lang="en-US" sz="1200" b="1" kern="0" spc="200" dirty="0">
                 <a:solidFill>
                   <a:srgbClr val="4F46E5"/>
                 </a:solidFill>
@@ -8785,7 +9037,7 @@
           <a:bodyPr wrap="square" rtlCol="0" anchor="ctr"/>
           <a:lstStyle/>
           <a:p>
-            <a:pPr indent="0" marL="0">
+            <a:pPr marL="0" indent="0">
               <a:buNone/>
             </a:pPr>
             <a:r>
@@ -8956,13 +9208,20 @@
             <a:prstDash val="solid"/>
           </a:ln>
           <a:effectLst>
-            <a:outerShdw sx="100000" sy="100000" kx="0" ky="0" algn="bl" rotWithShape="0" blurRad="101600" dist="25400" dir="5400000">
+            <a:outerShdw blurRad="101600" dist="25400" dir="5400000" algn="bl" rotWithShape="0">
               <a:srgbClr val="B9C2D0">
                 <a:alpha val="35000"/>
               </a:srgbClr>
             </a:outerShdw>
           </a:effectLst>
         </p:spPr>
+        <p:txBody>
+          <a:bodyPr/>
+          <a:lstStyle/>
+          <a:p>
+            <a:endParaRPr lang="en-IN"/>
+          </a:p>
+        </p:txBody>
       </p:sp>
       <p:sp>
         <p:nvSpPr>
@@ -8985,7 +9244,7 @@
           <a:bodyPr wrap="square" rtlCol="0" anchor="ctr"/>
           <a:lstStyle/>
           <a:p>
-            <a:pPr algn="ctr" indent="0" marL="0">
+            <a:pPr marL="0" indent="0" algn="ctr">
               <a:buNone/>
             </a:pPr>
             <a:r>
@@ -9024,7 +9283,7 @@
           <a:bodyPr wrap="square" rtlCol="0" anchor="ctr"/>
           <a:lstStyle/>
           <a:p>
-            <a:pPr algn="ctr" indent="0" marL="0">
+            <a:pPr marL="0" indent="0" algn="ctr">
               <a:buNone/>
             </a:pPr>
             <a:r>
@@ -9063,7 +9322,7 @@
           <a:bodyPr wrap="square" rtlCol="0" anchor="ctr"/>
           <a:lstStyle/>
           <a:p>
-            <a:pPr algn="ctr" indent="0" marL="0">
+            <a:pPr marL="0" indent="0" algn="ctr">
               <a:buNone/>
             </a:pPr>
             <a:r>
@@ -9100,6 +9359,13 @@
           </a:solidFill>
           <a:ln/>
         </p:spPr>
+        <p:txBody>
+          <a:bodyPr/>
+          <a:lstStyle/>
+          <a:p>
+            <a:endParaRPr lang="en-IN"/>
+          </a:p>
+        </p:txBody>
       </p:sp>
       <p:sp>
         <p:nvSpPr>
@@ -9122,7 +9388,7 @@
           <a:bodyPr wrap="square" rtlCol="0" anchor="ctr"/>
           <a:lstStyle/>
           <a:p>
-            <a:pPr indent="0" marL="0">
+            <a:pPr marL="0" indent="0">
               <a:buNone/>
             </a:pPr>
             <a:r>
@@ -9161,7 +9427,7 @@
           <a:bodyPr wrap="square" rtlCol="0" anchor="ctr"/>
           <a:lstStyle/>
           <a:p>
-            <a:pPr algn="r" indent="0" marL="0">
+            <a:pPr marL="0" indent="0" algn="r">
               <a:buNone/>
             </a:pPr>
             <a:r>
@@ -9195,6 +9461,7 @@
         <a:solidFill>
           <a:srgbClr val="F5F7FB"/>
         </a:solidFill>
+        <a:effectLst/>
       </p:bgPr>
     </p:bg>
     <p:spTree>
@@ -9232,11 +9499,11 @@
           <a:bodyPr wrap="square" rtlCol="0" anchor="ctr"/>
           <a:lstStyle/>
           <a:p>
-            <a:pPr indent="0" marL="0">
-              <a:buNone/>
-            </a:pPr>
-            <a:r>
-              <a:rPr lang="en-US" sz="1200" b="1" spc="200" kern="0" dirty="0">
+            <a:pPr marL="0" indent="0">
+              <a:buNone/>
+            </a:pPr>
+            <a:r>
+              <a:rPr lang="en-US" sz="1200" b="1" kern="0" spc="200" dirty="0">
                 <a:solidFill>
                   <a:srgbClr val="4F46E5"/>
                 </a:solidFill>
@@ -9271,7 +9538,7 @@
           <a:bodyPr wrap="square" rtlCol="0" anchor="ctr"/>
           <a:lstStyle/>
           <a:p>
-            <a:pPr indent="0" marL="0">
+            <a:pPr marL="0" indent="0">
               <a:buNone/>
             </a:pPr>
             <a:r>
@@ -9315,6 +9582,13 @@
             <a:prstDash val="solid"/>
           </a:ln>
         </p:spPr>
+        <p:txBody>
+          <a:bodyPr/>
+          <a:lstStyle/>
+          <a:p>
+            <a:endParaRPr lang="en-IN"/>
+          </a:p>
+        </p:txBody>
       </p:sp>
       <p:sp>
         <p:nvSpPr>
@@ -9335,6 +9609,13 @@
           </a:solidFill>
           <a:ln/>
         </p:spPr>
+        <p:txBody>
+          <a:bodyPr/>
+          <a:lstStyle/>
+          <a:p>
+            <a:endParaRPr lang="en-IN"/>
+          </a:p>
+        </p:txBody>
       </p:sp>
       <p:sp>
         <p:nvSpPr>
@@ -9357,7 +9638,7 @@
           <a:bodyPr wrap="square" rtlCol="0" anchor="ctr"/>
           <a:lstStyle/>
           <a:p>
-            <a:pPr indent="0" marL="0">
+            <a:pPr marL="0" indent="0">
               <a:buNone/>
             </a:pPr>
             <a:r>
@@ -9396,7 +9677,7 @@
           <a:bodyPr wrap="square" rtlCol="0" anchor="t"/>
           <a:lstStyle/>
           <a:p>
-            <a:pPr indent="0" marL="0">
+            <a:pPr marL="0" indent="0">
               <a:buNone/>
             </a:pPr>
             <a:r>
@@ -9413,7 +9694,7 @@
             <a:endParaRPr lang="en-US" sz="1100" dirty="0"/>
           </a:p>
           <a:p>
-            <a:pPr indent="0" marL="0">
+            <a:pPr marL="0" indent="0">
               <a:buNone/>
             </a:pPr>
             <a:r>
@@ -9457,6 +9738,13 @@
             <a:prstDash val="solid"/>
           </a:ln>
         </p:spPr>
+        <p:txBody>
+          <a:bodyPr/>
+          <a:lstStyle/>
+          <a:p>
+            <a:endParaRPr lang="en-IN"/>
+          </a:p>
+        </p:txBody>
       </p:sp>
       <p:sp>
         <p:nvSpPr>
@@ -9477,6 +9765,13 @@
           </a:solidFill>
           <a:ln/>
         </p:spPr>
+        <p:txBody>
+          <a:bodyPr/>
+          <a:lstStyle/>
+          <a:p>
+            <a:endParaRPr lang="en-IN"/>
+          </a:p>
+        </p:txBody>
       </p:sp>
       <p:sp>
         <p:nvSpPr>
@@ -9499,7 +9794,7 @@
           <a:bodyPr wrap="square" rtlCol="0" anchor="ctr"/>
           <a:lstStyle/>
           <a:p>
-            <a:pPr indent="0" marL="0">
+            <a:pPr marL="0" indent="0">
               <a:buNone/>
             </a:pPr>
             <a:r>
@@ -9538,7 +9833,7 @@
           <a:bodyPr wrap="square" rtlCol="0" anchor="t"/>
           <a:lstStyle/>
           <a:p>
-            <a:pPr indent="0" marL="0">
+            <a:pPr marL="0" indent="0">
               <a:buNone/>
             </a:pPr>
             <a:r>
@@ -9555,7 +9850,7 @@
             <a:endParaRPr lang="en-US" sz="1100" dirty="0"/>
           </a:p>
           <a:p>
-            <a:pPr indent="0" marL="0">
+            <a:pPr marL="0" indent="0">
               <a:buNone/>
             </a:pPr>
             <a:r>
@@ -9599,6 +9894,13 @@
             <a:prstDash val="solid"/>
           </a:ln>
         </p:spPr>
+        <p:txBody>
+          <a:bodyPr/>
+          <a:lstStyle/>
+          <a:p>
+            <a:endParaRPr lang="en-IN"/>
+          </a:p>
+        </p:txBody>
       </p:sp>
       <p:sp>
         <p:nvSpPr>
@@ -9619,6 +9921,13 @@
           </a:solidFill>
           <a:ln/>
         </p:spPr>
+        <p:txBody>
+          <a:bodyPr/>
+          <a:lstStyle/>
+          <a:p>
+            <a:endParaRPr lang="en-IN"/>
+          </a:p>
+        </p:txBody>
       </p:sp>
       <p:sp>
         <p:nvSpPr>
@@ -9641,7 +9950,7 @@
           <a:bodyPr wrap="square" rtlCol="0" anchor="ctr"/>
           <a:lstStyle/>
           <a:p>
-            <a:pPr indent="0" marL="0">
+            <a:pPr marL="0" indent="0">
               <a:buNone/>
             </a:pPr>
             <a:r>
@@ -9680,7 +9989,7 @@
           <a:bodyPr wrap="square" rtlCol="0" anchor="t"/>
           <a:lstStyle/>
           <a:p>
-            <a:pPr indent="0" marL="0">
+            <a:pPr marL="0" indent="0">
               <a:buNone/>
             </a:pPr>
             <a:r>
@@ -9717,6 +10026,13 @@
           </a:solidFill>
           <a:ln/>
         </p:spPr>
+        <p:txBody>
+          <a:bodyPr/>
+          <a:lstStyle/>
+          <a:p>
+            <a:endParaRPr lang="en-IN"/>
+          </a:p>
+        </p:txBody>
       </p:sp>
       <p:sp>
         <p:nvSpPr>
@@ -9737,6 +10053,13 @@
           </a:solidFill>
           <a:ln/>
         </p:spPr>
+        <p:txBody>
+          <a:bodyPr/>
+          <a:lstStyle/>
+          <a:p>
+            <a:endParaRPr lang="en-IN"/>
+          </a:p>
+        </p:txBody>
       </p:sp>
       <p:sp>
         <p:nvSpPr>
@@ -9759,7 +10082,7 @@
           <a:bodyPr wrap="square" rtlCol="0" anchor="ctr"/>
           <a:lstStyle/>
           <a:p>
-            <a:pPr indent="0" marL="0">
+            <a:pPr marL="0" indent="0">
               <a:buNone/>
             </a:pPr>
             <a:r>
@@ -9803,13 +10126,20 @@
             <a:prstDash val="solid"/>
           </a:ln>
           <a:effectLst>
-            <a:outerShdw sx="100000" sy="100000" kx="0" ky="0" algn="bl" rotWithShape="0" blurRad="101600" dist="25400" dir="5400000">
+            <a:outerShdw blurRad="101600" dist="25400" dir="5400000" algn="bl" rotWithShape="0">
               <a:srgbClr val="B9C2D0">
                 <a:alpha val="35000"/>
               </a:srgbClr>
             </a:outerShdw>
           </a:effectLst>
         </p:spPr>
+        <p:txBody>
+          <a:bodyPr/>
+          <a:lstStyle/>
+          <a:p>
+            <a:endParaRPr lang="en-IN"/>
+          </a:p>
+        </p:txBody>
       </p:sp>
       <p:sp>
         <p:nvSpPr>
@@ -9832,7 +10162,7 @@
           <a:bodyPr wrap="square" rtlCol="0" anchor="ctr"/>
           <a:lstStyle/>
           <a:p>
-            <a:pPr indent="0" marL="0">
+            <a:pPr marL="0" indent="0">
               <a:buNone/>
             </a:pPr>
             <a:r>
@@ -9933,6 +10263,13 @@
           </a:solidFill>
           <a:ln/>
         </p:spPr>
+        <p:txBody>
+          <a:bodyPr/>
+          <a:lstStyle/>
+          <a:p>
+            <a:endParaRPr lang="en-IN"/>
+          </a:p>
+        </p:txBody>
       </p:sp>
       <p:sp>
         <p:nvSpPr>
@@ -9955,7 +10292,7 @@
           <a:bodyPr wrap="square" rtlCol="0" anchor="ctr"/>
           <a:lstStyle/>
           <a:p>
-            <a:pPr indent="0" marL="0">
+            <a:pPr marL="0" indent="0">
               <a:buNone/>
             </a:pPr>
             <a:r>
@@ -9994,7 +10331,7 @@
           <a:bodyPr wrap="square" rtlCol="0" anchor="ctr"/>
           <a:lstStyle/>
           <a:p>
-            <a:pPr algn="r" indent="0" marL="0">
+            <a:pPr marL="0" indent="0" algn="r">
               <a:buNone/>
             </a:pPr>
             <a:r>
@@ -10313,4 +10650,319 @@
     </a:ext>
   </a:extLst>
 </a:theme>
+</file>
+
+<file path=ppt/theme/theme2.xml><?xml version="1.0" encoding="utf-8"?>
+<a:theme xmlns:a="http://schemas.openxmlformats.org/drawingml/2006/main" name="Office Theme">
+  <a:themeElements>
+    <a:clrScheme name="Office">
+      <a:dk1>
+        <a:sysClr val="windowText" lastClr="000000"/>
+      </a:dk1>
+      <a:lt1>
+        <a:sysClr val="window" lastClr="FFFFFF"/>
+      </a:lt1>
+      <a:dk2>
+        <a:srgbClr val="0E2841"/>
+      </a:dk2>
+      <a:lt2>
+        <a:srgbClr val="E8E8E8"/>
+      </a:lt2>
+      <a:accent1>
+        <a:srgbClr val="156082"/>
+      </a:accent1>
+      <a:accent2>
+        <a:srgbClr val="E97132"/>
+      </a:accent2>
+      <a:accent3>
+        <a:srgbClr val="196B24"/>
+      </a:accent3>
+      <a:accent4>
+        <a:srgbClr val="0F9ED5"/>
+      </a:accent4>
+      <a:accent5>
+        <a:srgbClr val="A02B93"/>
+      </a:accent5>
+      <a:accent6>
+        <a:srgbClr val="4EA72E"/>
+      </a:accent6>
+      <a:hlink>
+        <a:srgbClr val="467886"/>
+      </a:hlink>
+      <a:folHlink>
+        <a:srgbClr val="96607D"/>
+      </a:folHlink>
+    </a:clrScheme>
+    <a:fontScheme name="Office">
+      <a:majorFont>
+        <a:latin typeface="Aptos Display" panose="02110004020202020204"/>
+        <a:ea typeface=""/>
+        <a:cs typeface=""/>
+        <a:font script="Jpan" typeface="游ゴシック Light"/>
+        <a:font script="Hang" typeface="맑은 고딕"/>
+        <a:font script="Hans" typeface="等线 Light"/>
+        <a:font script="Hant" typeface="新細明體"/>
+        <a:font script="Arab" typeface="Times New Roman"/>
+        <a:font script="Hebr" typeface="Times New Roman"/>
+        <a:font script="Thai" typeface="Angsana New"/>
+        <a:font script="Ethi" typeface="Nyala"/>
+        <a:font script="Beng" typeface="Vrinda"/>
+        <a:font script="Gujr" typeface="Shruti"/>
+        <a:font script="Khmr" typeface="MoolBoran"/>
+        <a:font script="Knda" typeface="Tunga"/>
+        <a:font script="Guru" typeface="Raavi"/>
+        <a:font script="Cans" typeface="Euphemia"/>
+        <a:font script="Cher" typeface="Plantagenet Cherokee"/>
+        <a:font script="Yiii" typeface="Microsoft Yi Baiti"/>
+        <a:font script="Tibt" typeface="Microsoft Himalaya"/>
+        <a:font script="Thaa" typeface="MV Boli"/>
+        <a:font script="Deva" typeface="Mangal"/>
+        <a:font script="Telu" typeface="Gautami"/>
+        <a:font script="Taml" typeface="Latha"/>
+        <a:font script="Syrc" typeface="Estrangelo Edessa"/>
+        <a:font script="Orya" typeface="Kalinga"/>
+        <a:font script="Mlym" typeface="Kartika"/>
+        <a:font script="Laoo" typeface="DokChampa"/>
+        <a:font script="Sinh" typeface="Iskoola Pota"/>
+        <a:font script="Mong" typeface="Mongolian Baiti"/>
+        <a:font script="Viet" typeface="Times New Roman"/>
+        <a:font script="Uigh" typeface="Microsoft Uighur"/>
+        <a:font script="Geor" typeface="Sylfaen"/>
+        <a:font script="Armn" typeface="Arial"/>
+        <a:font script="Bugi" typeface="Leelawadee UI"/>
+        <a:font script="Bopo" typeface="Microsoft JhengHei"/>
+        <a:font script="Java" typeface="Javanese Text"/>
+        <a:font script="Lisu" typeface="Segoe UI"/>
+        <a:font script="Mymr" typeface="Myanmar Text"/>
+        <a:font script="Nkoo" typeface="Ebrima"/>
+        <a:font script="Olck" typeface="Nirmala UI"/>
+        <a:font script="Osma" typeface="Ebrima"/>
+        <a:font script="Phag" typeface="Phagspa"/>
+        <a:font script="Syrn" typeface="Estrangelo Edessa"/>
+        <a:font script="Syrj" typeface="Estrangelo Edessa"/>
+        <a:font script="Syre" typeface="Estrangelo Edessa"/>
+        <a:font script="Sora" typeface="Nirmala UI"/>
+        <a:font script="Tale" typeface="Microsoft Tai Le"/>
+        <a:font script="Talu" typeface="Microsoft New Tai Lue"/>
+        <a:font script="Tfng" typeface="Ebrima"/>
+      </a:majorFont>
+      <a:minorFont>
+        <a:latin typeface="Aptos" panose="02110004020202020204"/>
+        <a:ea typeface=""/>
+        <a:cs typeface=""/>
+        <a:font script="Jpan" typeface="游ゴシック"/>
+        <a:font script="Hang" typeface="맑은 고딕"/>
+        <a:font script="Hans" typeface="等线"/>
+        <a:font script="Hant" typeface="新細明體"/>
+        <a:font script="Arab" typeface="Arial"/>
+        <a:font script="Hebr" typeface="Arial"/>
+        <a:font script="Thai" typeface="Cordia New"/>
+        <a:font script="Ethi" typeface="Nyala"/>
+        <a:font script="Beng" typeface="Vrinda"/>
+        <a:font script="Gujr" typeface="Shruti"/>
+        <a:font script="Khmr" typeface="DaunPenh"/>
+        <a:font script="Knda" typeface="Tunga"/>
+        <a:font script="Guru" typeface="Raavi"/>
+        <a:font script="Cans" typeface="Euphemia"/>
+        <a:font script="Cher" typeface="Plantagenet Cherokee"/>
+        <a:font script="Yiii" typeface="Microsoft Yi Baiti"/>
+        <a:font script="Tibt" typeface="Microsoft Himalaya"/>
+        <a:font script="Thaa" typeface="MV Boli"/>
+        <a:font script="Deva" typeface="Mangal"/>
+        <a:font script="Telu" typeface="Gautami"/>
+        <a:font script="Taml" typeface="Latha"/>
+        <a:font script="Syrc" typeface="Estrangelo Edessa"/>
+        <a:font script="Orya" typeface="Kalinga"/>
+        <a:font script="Mlym" typeface="Kartika"/>
+        <a:font script="Laoo" typeface="DokChampa"/>
+        <a:font script="Sinh" typeface="Iskoola Pota"/>
+        <a:font script="Mong" typeface="Mongolian Baiti"/>
+        <a:font script="Viet" typeface="Arial"/>
+        <a:font script="Uigh" typeface="Microsoft Uighur"/>
+        <a:font script="Geor" typeface="Sylfaen"/>
+        <a:font script="Armn" typeface="Arial"/>
+        <a:font script="Bugi" typeface="Leelawadee UI"/>
+        <a:font script="Bopo" typeface="Microsoft JhengHei"/>
+        <a:font script="Java" typeface="Javanese Text"/>
+        <a:font script="Lisu" typeface="Segoe UI"/>
+        <a:font script="Mymr" typeface="Myanmar Text"/>
+        <a:font script="Nkoo" typeface="Ebrima"/>
+        <a:font script="Olck" typeface="Nirmala UI"/>
+        <a:font script="Osma" typeface="Ebrima"/>
+        <a:font script="Phag" typeface="Phagspa"/>
+        <a:font script="Syrn" typeface="Estrangelo Edessa"/>
+        <a:font script="Syrj" typeface="Estrangelo Edessa"/>
+        <a:font script="Syre" typeface="Estrangelo Edessa"/>
+        <a:font script="Sora" typeface="Nirmala UI"/>
+        <a:font script="Tale" typeface="Microsoft Tai Le"/>
+        <a:font script="Talu" typeface="Microsoft New Tai Lue"/>
+        <a:font script="Tfng" typeface="Ebrima"/>
+      </a:minorFont>
+    </a:fontScheme>
+    <a:fmtScheme name="Office">
+      <a:fillStyleLst>
+        <a:solidFill>
+          <a:schemeClr val="phClr"/>
+        </a:solidFill>
+        <a:gradFill rotWithShape="1">
+          <a:gsLst>
+            <a:gs pos="0">
+              <a:schemeClr val="phClr">
+                <a:lumMod val="110000"/>
+                <a:satMod val="105000"/>
+                <a:tint val="67000"/>
+              </a:schemeClr>
+            </a:gs>
+            <a:gs pos="50000">
+              <a:schemeClr val="phClr">
+                <a:lumMod val="105000"/>
+                <a:satMod val="103000"/>
+                <a:tint val="73000"/>
+              </a:schemeClr>
+            </a:gs>
+            <a:gs pos="100000">
+              <a:schemeClr val="phClr">
+                <a:lumMod val="105000"/>
+                <a:satMod val="109000"/>
+                <a:tint val="81000"/>
+              </a:schemeClr>
+            </a:gs>
+          </a:gsLst>
+          <a:lin ang="5400000" scaled="0"/>
+        </a:gradFill>
+        <a:gradFill rotWithShape="1">
+          <a:gsLst>
+            <a:gs pos="0">
+              <a:schemeClr val="phClr">
+                <a:satMod val="103000"/>
+                <a:lumMod val="102000"/>
+                <a:tint val="94000"/>
+              </a:schemeClr>
+            </a:gs>
+            <a:gs pos="50000">
+              <a:schemeClr val="phClr">
+                <a:satMod val="110000"/>
+                <a:lumMod val="100000"/>
+                <a:shade val="100000"/>
+              </a:schemeClr>
+            </a:gs>
+            <a:gs pos="100000">
+              <a:schemeClr val="phClr">
+                <a:lumMod val="99000"/>
+                <a:satMod val="120000"/>
+                <a:shade val="78000"/>
+              </a:schemeClr>
+            </a:gs>
+          </a:gsLst>
+          <a:lin ang="5400000" scaled="0"/>
+        </a:gradFill>
+      </a:fillStyleLst>
+      <a:lnStyleLst>
+        <a:ln w="12700" cap="flat" cmpd="sng" algn="ctr">
+          <a:solidFill>
+            <a:schemeClr val="phClr"/>
+          </a:solidFill>
+          <a:prstDash val="solid"/>
+          <a:miter lim="800000"/>
+        </a:ln>
+        <a:ln w="19050" cap="flat" cmpd="sng" algn="ctr">
+          <a:solidFill>
+            <a:schemeClr val="phClr"/>
+          </a:solidFill>
+          <a:prstDash val="solid"/>
+          <a:miter lim="800000"/>
+        </a:ln>
+        <a:ln w="25400" cap="flat" cmpd="sng" algn="ctr">
+          <a:solidFill>
+            <a:schemeClr val="phClr"/>
+          </a:solidFill>
+          <a:prstDash val="solid"/>
+          <a:miter lim="800000"/>
+        </a:ln>
+      </a:lnStyleLst>
+      <a:effectStyleLst>
+        <a:effectStyle>
+          <a:effectLst/>
+        </a:effectStyle>
+        <a:effectStyle>
+          <a:effectLst/>
+        </a:effectStyle>
+        <a:effectStyle>
+          <a:effectLst>
+            <a:outerShdw blurRad="57150" dist="19050" dir="5400000" algn="ctr" rotWithShape="0">
+              <a:srgbClr val="000000">
+                <a:alpha val="63000"/>
+              </a:srgbClr>
+            </a:outerShdw>
+          </a:effectLst>
+        </a:effectStyle>
+      </a:effectStyleLst>
+      <a:bgFillStyleLst>
+        <a:solidFill>
+          <a:schemeClr val="phClr"/>
+        </a:solidFill>
+        <a:solidFill>
+          <a:schemeClr val="phClr">
+            <a:tint val="95000"/>
+            <a:satMod val="170000"/>
+          </a:schemeClr>
+        </a:solidFill>
+        <a:gradFill rotWithShape="1">
+          <a:gsLst>
+            <a:gs pos="0">
+              <a:schemeClr val="phClr">
+                <a:tint val="93000"/>
+                <a:satMod val="150000"/>
+                <a:shade val="98000"/>
+                <a:lumMod val="102000"/>
+              </a:schemeClr>
+            </a:gs>
+            <a:gs pos="50000">
+              <a:schemeClr val="phClr">
+                <a:tint val="98000"/>
+                <a:satMod val="130000"/>
+                <a:shade val="90000"/>
+                <a:lumMod val="103000"/>
+              </a:schemeClr>
+            </a:gs>
+            <a:gs pos="100000">
+              <a:schemeClr val="phClr">
+                <a:shade val="63000"/>
+                <a:satMod val="120000"/>
+              </a:schemeClr>
+            </a:gs>
+          </a:gsLst>
+          <a:lin ang="5400000" scaled="0"/>
+        </a:gradFill>
+      </a:bgFillStyleLst>
+    </a:fmtScheme>
+  </a:themeElements>
+  <a:objectDefaults>
+    <a:lnDef>
+      <a:spPr/>
+      <a:bodyPr/>
+      <a:lstStyle/>
+      <a:style>
+        <a:lnRef idx="2">
+          <a:schemeClr val="accent1"/>
+        </a:lnRef>
+        <a:fillRef idx="0">
+          <a:schemeClr val="accent1"/>
+        </a:fillRef>
+        <a:effectRef idx="1">
+          <a:schemeClr val="accent1"/>
+        </a:effectRef>
+        <a:fontRef idx="minor">
+          <a:schemeClr val="tx1"/>
+        </a:fontRef>
+      </a:style>
+    </a:lnDef>
+  </a:objectDefaults>
+  <a:extraClrSchemeLst/>
+  <a:extLst>
+    <a:ext uri="{05A4C25C-085E-4340-85A3-A5531E510DB2}">
+      <thm15:themeFamily xmlns:thm15="http://schemas.microsoft.com/office/thememl/2012/main" name="Office Theme" id="{2E142A2C-CD16-42D6-873A-C26D2A0506FA}" vid="{1BDDFF52-6CD6-40A5-AB3C-68EB2F1E4D0A}"/>
+    </a:ext>
+  </a:extLst>
+</a:theme>
 </file>
</xml_diff>